<commit_message>
simplify structure of shiftlines according to Voith-Proposal: no interpolation for load-stage 5, put average values into vgsv file directly
</commit_message>
<xml_diff>
--- a/Documentation/User Manual Source/DocumentationGearshiftModels.pptx
+++ b/Documentation/User Manual Source/DocumentationGearshiftModels.pptx
@@ -5,10 +5,10 @@
     <p:sldMasterId id="2147483648" r:id="rId1"/>
   </p:sldMasterIdLst>
   <p:notesMasterIdLst>
-    <p:notesMasterId r:id="rId21"/>
+    <p:notesMasterId r:id="rId20"/>
   </p:notesMasterIdLst>
   <p:handoutMasterIdLst>
-    <p:handoutMasterId r:id="rId22"/>
+    <p:handoutMasterId r:id="rId21"/>
   </p:handoutMasterIdLst>
   <p:sldIdLst>
     <p:sldId id="575" r:id="rId2"/>
@@ -26,10 +26,9 @@
     <p:sldId id="693" r:id="rId14"/>
     <p:sldId id="694" r:id="rId15"/>
     <p:sldId id="695" r:id="rId16"/>
-    <p:sldId id="698" r:id="rId17"/>
-    <p:sldId id="696" r:id="rId18"/>
-    <p:sldId id="697" r:id="rId19"/>
-    <p:sldId id="699" r:id="rId20"/>
+    <p:sldId id="696" r:id="rId17"/>
+    <p:sldId id="697" r:id="rId18"/>
+    <p:sldId id="699" r:id="rId19"/>
   </p:sldIdLst>
   <p:sldSz cx="9144000" cy="6858000" type="screen4x3"/>
   <p:notesSz cx="6805613" cy="9944100"/>
@@ -4728,11 +4727,7 @@
             </a:r>
             <a:r>
               <a:rPr lang="en-US" sz="1600" dirty="0" smtClean="0"/>
-              <a:t> </a:t>
-            </a:r>
-            <a:r>
-              <a:rPr lang="en-US" sz="1600" dirty="0" smtClean="0"/>
-              <a:t>model</a:t>
+              <a:t> model</a:t>
             </a:r>
           </a:p>
           <a:p>
@@ -4745,7 +4740,6 @@
               <a:rPr lang="en-US" sz="1400" dirty="0" smtClean="0"/>
               <a:t>Limitation: not tested for gearboxes with 2 torque converter gears</a:t>
             </a:r>
-            <a:endParaRPr lang="en-US" sz="1400" dirty="0" smtClean="0"/>
           </a:p>
         </p:txBody>
       </p:sp>
@@ -5331,28 +5325,26 @@
             <a:pPr lvl="1"/>
             <a:r>
               <a:rPr lang="en-US" sz="1400" dirty="0" smtClean="0"/>
-              <a:t>For every load-stage, an upper and lower shift line is defined for downhill (-5%), level (0%), and uphill (+5%)</a:t>
-            </a:r>
-          </a:p>
-          <a:p>
-            <a:pPr lvl="2"/>
-            <a:r>
-              <a:rPr lang="en-US" sz="1000" dirty="0" smtClean="0"/>
-              <a:t>The shift speed is interpolated between upper and lower bound</a:t>
-            </a:r>
-          </a:p>
-          <a:p>
-            <a:pPr lvl="2"/>
-            <a:r>
-              <a:rPr lang="en-US" sz="1000" dirty="0" smtClean="0"/>
-              <a:t>If no interpolation is intended, set the upper and lower bound shift line to the same values</a:t>
+              <a:t>For every load-stage, </a:t>
+            </a:r>
+            <a:r>
+              <a:rPr lang="en-US" sz="1400" dirty="0" smtClean="0"/>
+              <a:t>a shift </a:t>
+            </a:r>
+            <a:r>
+              <a:rPr lang="en-US" sz="1400" dirty="0" smtClean="0"/>
+              <a:t>line is defined for downhill (-5%), level (0%), and uphill (+5%)</a:t>
             </a:r>
           </a:p>
           <a:p>
             <a:pPr lvl="1"/>
             <a:r>
               <a:rPr lang="en-US" sz="1400" dirty="0" smtClean="0"/>
-              <a:t>For both, the upper and lower bound shift lines, the shift speed for </a:t>
+              <a:t>For the shift </a:t>
+            </a:r>
+            <a:r>
+              <a:rPr lang="en-US" sz="1400" dirty="0" smtClean="0"/>
+              <a:t>lines, the shift speed for </a:t>
             </a:r>
             <a:r>
               <a:rPr lang="en-US" sz="1400" dirty="0" err="1" smtClean="0"/>
@@ -5437,7 +5429,15 @@
             <a:pPr lvl="2"/>
             <a:r>
               <a:rPr lang="en-US" sz="1000" dirty="0" smtClean="0"/>
-              <a:t>The lower bound shift speeds for </a:t>
+              <a:t>The </a:t>
+            </a:r>
+            <a:r>
+              <a:rPr lang="en-US" sz="1000" dirty="0" smtClean="0"/>
+              <a:t>shift </a:t>
+            </a:r>
+            <a:r>
+              <a:rPr lang="en-US" sz="1000" dirty="0" smtClean="0"/>
+              <a:t>speeds for </a:t>
             </a:r>
             <a:r>
               <a:rPr lang="en-US" sz="1000" dirty="0" err="1" smtClean="0"/>
@@ -5456,7 +5456,15 @@
             <a:pPr lvl="2"/>
             <a:r>
               <a:rPr lang="en-US" sz="1000" dirty="0" smtClean="0"/>
-              <a:t>If the lower bound shift speeds for </a:t>
+              <a:t>If the </a:t>
+            </a:r>
+            <a:r>
+              <a:rPr lang="en-US" sz="1000" dirty="0" smtClean="0"/>
+              <a:t>shift </a:t>
+            </a:r>
+            <a:r>
+              <a:rPr lang="en-US" sz="1000" dirty="0" smtClean="0"/>
+              <a:t>speeds for </a:t>
             </a:r>
             <a:r>
               <a:rPr lang="en-US" sz="1000" dirty="0" err="1" smtClean="0"/>
@@ -5468,7 +5476,15 @@
             </a:r>
             <a:r>
               <a:rPr lang="en-US" sz="1000" dirty="0" smtClean="0"/>
-              <a:t> are missing, the lower bound shift speeds for </a:t>
+              <a:t> are missing, the </a:t>
+            </a:r>
+            <a:r>
+              <a:rPr lang="en-US" sz="1000" dirty="0" smtClean="0"/>
+              <a:t>shift </a:t>
+            </a:r>
+            <a:r>
+              <a:rPr lang="en-US" sz="1000" dirty="0" smtClean="0"/>
+              <a:t>speeds for </a:t>
             </a:r>
             <a:r>
               <a:rPr lang="en-US" sz="1000" dirty="0" err="1" smtClean="0"/>
@@ -5484,78 +5500,10 @@
             </a:r>
           </a:p>
           <a:p>
-            <a:pPr lvl="2"/>
-            <a:r>
-              <a:rPr lang="en-US" sz="1000" dirty="0" smtClean="0"/>
-              <a:t>If the upper bound shift speeds for </a:t>
-            </a:r>
-            <a:r>
-              <a:rPr lang="en-US" sz="1000" dirty="0" err="1" smtClean="0"/>
-              <a:t>a</a:t>
-            </a:r>
-            <a:r>
-              <a:rPr lang="en-US" sz="1000" baseline="-25000" dirty="0" err="1" smtClean="0"/>
-              <a:t>max</a:t>
-            </a:r>
-            <a:r>
-              <a:rPr lang="en-US" sz="1000" dirty="0" smtClean="0"/>
-              <a:t> are missing, the values from the lower bound shift lines for </a:t>
-            </a:r>
-            <a:r>
-              <a:rPr lang="en-US" sz="1000" dirty="0" err="1" smtClean="0"/>
-              <a:t>a</a:t>
-            </a:r>
-            <a:r>
-              <a:rPr lang="en-US" sz="1000" baseline="-25000" dirty="0" err="1" smtClean="0"/>
-              <a:t>max</a:t>
-            </a:r>
-            <a:r>
-              <a:rPr lang="en-US" sz="1000" dirty="0" smtClean="0"/>
-              <a:t> are used</a:t>
-            </a:r>
-          </a:p>
-          <a:p>
-            <a:pPr lvl="2"/>
-            <a:r>
-              <a:rPr lang="en-US" sz="1000" dirty="0" smtClean="0"/>
-              <a:t>If the upper bound shift speeds for </a:t>
-            </a:r>
-            <a:r>
-              <a:rPr lang="en-US" sz="1000" dirty="0" err="1" smtClean="0"/>
-              <a:t>a</a:t>
-            </a:r>
-            <a:r>
-              <a:rPr lang="en-US" sz="1000" baseline="-25000" dirty="0" err="1" smtClean="0"/>
-              <a:t>min</a:t>
-            </a:r>
-            <a:r>
-              <a:rPr lang="en-US" sz="1000" dirty="0" smtClean="0"/>
-              <a:t> are missing, either </a:t>
-            </a:r>
-            <a:r>
-              <a:rPr lang="en-US" sz="1000" dirty="0" err="1" smtClean="0"/>
-              <a:t>a</a:t>
-            </a:r>
-            <a:r>
-              <a:rPr lang="en-US" sz="1000" baseline="-25000" dirty="0" err="1"/>
-              <a:t>max</a:t>
-            </a:r>
-            <a:r>
-              <a:rPr lang="en-US" sz="1000" dirty="0" smtClean="0"/>
-              <a:t> from the upper bound or </a:t>
-            </a:r>
-            <a:r>
-              <a:rPr lang="en-US" sz="1000" dirty="0" err="1" smtClean="0"/>
-              <a:t>a</a:t>
-            </a:r>
-            <a:r>
-              <a:rPr lang="en-US" sz="1000" baseline="-25000" dirty="0" err="1"/>
-              <a:t>max</a:t>
-            </a:r>
-            <a:r>
-              <a:rPr lang="en-US" sz="1000" dirty="0" smtClean="0"/>
-              <a:t> from the lower bound is used</a:t>
-            </a:r>
+            <a:pPr marL="914400" lvl="2" indent="0">
+              <a:buNone/>
+            </a:pPr>
+            <a:endParaRPr lang="en-US" sz="1000" dirty="0" smtClean="0"/>
           </a:p>
         </p:txBody>
       </p:sp>
@@ -5726,109 +5674,144 @@
               <a:t> , </a:t>
             </a:r>
             <a:r>
-              <a:rPr lang="de-AT" sz="800" b="0" dirty="0" err="1">
+              <a:rPr lang="de-AT" sz="800" b="0" dirty="0" err="1" smtClean="0">
                 <a:latin typeface="Courier New" panose="02070309020205020404" pitchFamily="49" charset="0"/>
                 <a:cs typeface="Courier New" panose="02070309020205020404" pitchFamily="49" charset="0"/>
               </a:rPr>
-              <a:t>n_dh_amax_lower</a:t>
+              <a:t>n_dh_amax</a:t>
+            </a:r>
+            <a:r>
+              <a:rPr lang="de-AT" sz="800" b="0" dirty="0" smtClean="0">
+                <a:latin typeface="Courier New" panose="02070309020205020404" pitchFamily="49" charset="0"/>
+                <a:cs typeface="Courier New" panose="02070309020205020404" pitchFamily="49" charset="0"/>
+              </a:rPr>
+              <a:t> </a:t>
             </a:r>
             <a:r>
               <a:rPr lang="de-AT" sz="800" b="0" dirty="0">
                 <a:latin typeface="Courier New" panose="02070309020205020404" pitchFamily="49" charset="0"/>
                 <a:cs typeface="Courier New" panose="02070309020205020404" pitchFamily="49" charset="0"/>
               </a:rPr>
-              <a:t> , </a:t>
-            </a:r>
-            <a:r>
-              <a:rPr lang="de-AT" sz="800" b="0" dirty="0" err="1">
+              <a:t>, </a:t>
+            </a:r>
+            <a:r>
+              <a:rPr lang="de-AT" sz="800" b="0" dirty="0" err="1" smtClean="0">
                 <a:latin typeface="Courier New" panose="02070309020205020404" pitchFamily="49" charset="0"/>
                 <a:cs typeface="Courier New" panose="02070309020205020404" pitchFamily="49" charset="0"/>
               </a:rPr>
-              <a:t>n_level_amax_lower</a:t>
+              <a:t>n_level_amax</a:t>
+            </a:r>
+            <a:r>
+              <a:rPr lang="de-AT" sz="800" b="0" dirty="0" smtClean="0">
+                <a:latin typeface="Courier New" panose="02070309020205020404" pitchFamily="49" charset="0"/>
+                <a:cs typeface="Courier New" panose="02070309020205020404" pitchFamily="49" charset="0"/>
+              </a:rPr>
+              <a:t> </a:t>
             </a:r>
             <a:r>
               <a:rPr lang="de-AT" sz="800" b="0" dirty="0">
                 <a:latin typeface="Courier New" panose="02070309020205020404" pitchFamily="49" charset="0"/>
                 <a:cs typeface="Courier New" panose="02070309020205020404" pitchFamily="49" charset="0"/>
               </a:rPr>
-              <a:t> , </a:t>
-            </a:r>
-            <a:r>
-              <a:rPr lang="de-AT" sz="800" b="0" dirty="0" err="1">
+              <a:t>, </a:t>
+            </a:r>
+            <a:r>
+              <a:rPr lang="de-AT" sz="800" b="0" dirty="0" err="1" smtClean="0">
                 <a:latin typeface="Courier New" panose="02070309020205020404" pitchFamily="49" charset="0"/>
                 <a:cs typeface="Courier New" panose="02070309020205020404" pitchFamily="49" charset="0"/>
               </a:rPr>
-              <a:t>n_uh_amax_lower</a:t>
+              <a:t>n_uh_amax</a:t>
+            </a:r>
+            <a:r>
+              <a:rPr lang="de-AT" sz="800" b="0" dirty="0" smtClean="0">
+                <a:latin typeface="Courier New" panose="02070309020205020404" pitchFamily="49" charset="0"/>
+                <a:cs typeface="Courier New" panose="02070309020205020404" pitchFamily="49" charset="0"/>
+              </a:rPr>
+              <a:t> </a:t>
             </a:r>
             <a:r>
               <a:rPr lang="de-AT" sz="800" b="0" dirty="0">
                 <a:latin typeface="Courier New" panose="02070309020205020404" pitchFamily="49" charset="0"/>
                 <a:cs typeface="Courier New" panose="02070309020205020404" pitchFamily="49" charset="0"/>
               </a:rPr>
-              <a:t> , </a:t>
-            </a:r>
-            <a:r>
-              <a:rPr lang="de-AT" sz="800" b="0" dirty="0" err="1">
+              <a:t>, </a:t>
+            </a:r>
+            <a:r>
+              <a:rPr lang="de-AT" sz="800" b="0" dirty="0" err="1" smtClean="0">
                 <a:latin typeface="Courier New" panose="02070309020205020404" pitchFamily="49" charset="0"/>
                 <a:cs typeface="Courier New" panose="02070309020205020404" pitchFamily="49" charset="0"/>
               </a:rPr>
-              <a:t>n_dh_amin_lower</a:t>
+              <a:t>n_dh_amin</a:t>
+            </a:r>
+            <a:r>
+              <a:rPr lang="de-AT" sz="800" b="0" dirty="0" smtClean="0">
+                <a:latin typeface="Courier New" panose="02070309020205020404" pitchFamily="49" charset="0"/>
+                <a:cs typeface="Courier New" panose="02070309020205020404" pitchFamily="49" charset="0"/>
+              </a:rPr>
+              <a:t> </a:t>
             </a:r>
             <a:r>
               <a:rPr lang="de-AT" sz="800" b="0" dirty="0">
                 <a:latin typeface="Courier New" panose="02070309020205020404" pitchFamily="49" charset="0"/>
                 <a:cs typeface="Courier New" panose="02070309020205020404" pitchFamily="49" charset="0"/>
               </a:rPr>
-              <a:t> , </a:t>
-            </a:r>
-            <a:r>
-              <a:rPr lang="de-AT" sz="800" b="0" dirty="0" err="1">
+              <a:t>, </a:t>
+            </a:r>
+            <a:r>
+              <a:rPr lang="de-AT" sz="800" b="0" dirty="0" err="1" smtClean="0">
                 <a:latin typeface="Courier New" panose="02070309020205020404" pitchFamily="49" charset="0"/>
                 <a:cs typeface="Courier New" panose="02070309020205020404" pitchFamily="49" charset="0"/>
               </a:rPr>
-              <a:t>n_level_amin_lower</a:t>
+              <a:t>n_level_amin</a:t>
+            </a:r>
+            <a:r>
+              <a:rPr lang="de-AT" sz="800" b="0" dirty="0" smtClean="0">
+                <a:latin typeface="Courier New" panose="02070309020205020404" pitchFamily="49" charset="0"/>
+                <a:cs typeface="Courier New" panose="02070309020205020404" pitchFamily="49" charset="0"/>
+              </a:rPr>
+              <a:t> </a:t>
             </a:r>
             <a:r>
               <a:rPr lang="de-AT" sz="800" b="0" dirty="0">
                 <a:latin typeface="Courier New" panose="02070309020205020404" pitchFamily="49" charset="0"/>
                 <a:cs typeface="Courier New" panose="02070309020205020404" pitchFamily="49" charset="0"/>
               </a:rPr>
-              <a:t> , </a:t>
-            </a:r>
-            <a:r>
-              <a:rPr lang="de-AT" sz="800" b="0" dirty="0" err="1">
+              <a:t>, </a:t>
+            </a:r>
+            <a:r>
+              <a:rPr lang="de-AT" sz="800" b="0" dirty="0" err="1" smtClean="0">
                 <a:latin typeface="Courier New" panose="02070309020205020404" pitchFamily="49" charset="0"/>
                 <a:cs typeface="Courier New" panose="02070309020205020404" pitchFamily="49" charset="0"/>
               </a:rPr>
-              <a:t>n_uh_amin_lower</a:t>
-            </a:r>
-            <a:r>
-              <a:rPr lang="de-AT" sz="800" b="0" dirty="0">
-                <a:latin typeface="Courier New" panose="02070309020205020404" pitchFamily="49" charset="0"/>
-                <a:cs typeface="Courier New" panose="02070309020205020404" pitchFamily="49" charset="0"/>
-              </a:rPr>
-              <a:t> , </a:t>
-            </a:r>
+              <a:t>n_uh_amin</a:t>
+            </a:r>
+            <a:endParaRPr lang="de-AT" sz="800" b="0" dirty="0" smtClean="0">
+              <a:latin typeface="Courier New" panose="02070309020205020404" pitchFamily="49" charset="0"/>
+              <a:cs typeface="Courier New" panose="02070309020205020404" pitchFamily="49" charset="0"/>
+            </a:endParaRPr>
+          </a:p>
+          <a:p>
+            <a:pPr algn="l"/>
             <a:r>
               <a:rPr lang="de-AT" sz="800" b="0" dirty="0" smtClean="0">
                 <a:latin typeface="Courier New" panose="02070309020205020404" pitchFamily="49" charset="0"/>
                 <a:cs typeface="Courier New" panose="02070309020205020404" pitchFamily="49" charset="0"/>
               </a:rPr>
-              <a:t>[…]</a:t>
-            </a:r>
-            <a:endParaRPr lang="de-AT" sz="800" b="0" dirty="0" smtClean="0">
-              <a:latin typeface="Courier New" panose="02070309020205020404" pitchFamily="49" charset="0"/>
-              <a:cs typeface="Courier New" panose="02070309020205020404" pitchFamily="49" charset="0"/>
-            </a:endParaRPr>
-          </a:p>
-          <a:p>
-            <a:pPr algn="l"/>
+              <a:t>1-2   , 1         , 650      </a:t>
+            </a:r>
             <a:r>
               <a:rPr lang="de-AT" sz="800" b="0" dirty="0" smtClean="0">
                 <a:latin typeface="Courier New" panose="02070309020205020404" pitchFamily="49" charset="0"/>
                 <a:cs typeface="Courier New" panose="02070309020205020404" pitchFamily="49" charset="0"/>
               </a:rPr>
-              <a:t>1-2   , 1         , 650             , </a:t>
+              <a:t> </a:t>
+            </a:r>
+            <a:r>
+              <a:rPr lang="de-AT" sz="800" b="0" dirty="0" smtClean="0">
+                <a:latin typeface="Courier New" panose="02070309020205020404" pitchFamily="49" charset="0"/>
+                <a:cs typeface="Courier New" panose="02070309020205020404" pitchFamily="49" charset="0"/>
+              </a:rPr>
+              <a:t>, </a:t>
             </a:r>
             <a:r>
               <a:rPr lang="de-AT" sz="800" b="0" dirty="0" smtClean="0">
@@ -5845,14 +5828,28 @@
                 <a:latin typeface="Courier New" panose="02070309020205020404" pitchFamily="49" charset="0"/>
                 <a:cs typeface="Courier New" panose="02070309020205020404" pitchFamily="49" charset="0"/>
               </a:rPr>
-              <a:t>                , 725             ,                 ,                    ,                 </a:t>
-            </a:r>
-            <a:r>
-              <a:rPr lang="en-US" sz="800" b="0" dirty="0" smtClean="0">
+              <a:t>       </a:t>
+            </a:r>
+            <a:r>
+              <a:rPr lang="de-AT" sz="800" b="0" dirty="0" smtClean="0">
                 <a:latin typeface="Courier New" panose="02070309020205020404" pitchFamily="49" charset="0"/>
                 <a:cs typeface="Courier New" panose="02070309020205020404" pitchFamily="49" charset="0"/>
               </a:rPr>
-              <a:t>, […]</a:t>
+              <a:t>   </a:t>
+            </a:r>
+            <a:r>
+              <a:rPr lang="de-AT" sz="800" b="0" dirty="0" smtClean="0">
+                <a:latin typeface="Courier New" panose="02070309020205020404" pitchFamily="49" charset="0"/>
+                <a:cs typeface="Courier New" panose="02070309020205020404" pitchFamily="49" charset="0"/>
+              </a:rPr>
+              <a:t>, 725       </a:t>
+            </a:r>
+            <a:r>
+              <a:rPr lang="de-AT" sz="800" b="0" dirty="0" smtClean="0">
+                <a:latin typeface="Courier New" panose="02070309020205020404" pitchFamily="49" charset="0"/>
+                <a:cs typeface="Courier New" panose="02070309020205020404" pitchFamily="49" charset="0"/>
+              </a:rPr>
+              <a:t>,           ,              ,                 </a:t>
             </a:r>
             <a:endParaRPr lang="de-AT" sz="800" b="0" dirty="0" smtClean="0">
               <a:latin typeface="Courier New" panose="02070309020205020404" pitchFamily="49" charset="0"/>
@@ -6462,7 +6459,7 @@
         <p:spPr>
           <a:xfrm>
             <a:off x="977965" y="2057653"/>
-            <a:ext cx="14329592" cy="892552"/>
+            <a:ext cx="7626483" cy="769441"/>
           </a:xfrm>
           <a:prstGeom prst="rect">
             <a:avLst/>
@@ -6511,165 +6508,109 @@
               <a:t> , </a:t>
             </a:r>
             <a:r>
-              <a:rPr lang="de-AT" sz="800" b="0" dirty="0" err="1">
+              <a:rPr lang="de-AT" sz="800" b="0" dirty="0" err="1" smtClean="0">
                 <a:latin typeface="Courier New" panose="02070309020205020404" pitchFamily="49" charset="0"/>
                 <a:cs typeface="Courier New" panose="02070309020205020404" pitchFamily="49" charset="0"/>
               </a:rPr>
-              <a:t>n_dh_amax_lower</a:t>
+              <a:t>n_dh_amax</a:t>
+            </a:r>
+            <a:r>
+              <a:rPr lang="de-AT" sz="800" b="0" dirty="0" smtClean="0">
+                <a:latin typeface="Courier New" panose="02070309020205020404" pitchFamily="49" charset="0"/>
+                <a:cs typeface="Courier New" panose="02070309020205020404" pitchFamily="49" charset="0"/>
+              </a:rPr>
+              <a:t> </a:t>
             </a:r>
             <a:r>
               <a:rPr lang="de-AT" sz="800" b="0" dirty="0">
                 <a:latin typeface="Courier New" panose="02070309020205020404" pitchFamily="49" charset="0"/>
                 <a:cs typeface="Courier New" panose="02070309020205020404" pitchFamily="49" charset="0"/>
               </a:rPr>
-              <a:t> , </a:t>
-            </a:r>
-            <a:r>
-              <a:rPr lang="de-AT" sz="800" b="0" dirty="0" err="1">
+              <a:t>, </a:t>
+            </a:r>
+            <a:r>
+              <a:rPr lang="de-AT" sz="800" b="0" dirty="0" err="1" smtClean="0">
                 <a:latin typeface="Courier New" panose="02070309020205020404" pitchFamily="49" charset="0"/>
                 <a:cs typeface="Courier New" panose="02070309020205020404" pitchFamily="49" charset="0"/>
               </a:rPr>
-              <a:t>n_level_amax_lower</a:t>
+              <a:t>n_level_amax</a:t>
+            </a:r>
+            <a:r>
+              <a:rPr lang="de-AT" sz="800" b="0" dirty="0" smtClean="0">
+                <a:latin typeface="Courier New" panose="02070309020205020404" pitchFamily="49" charset="0"/>
+                <a:cs typeface="Courier New" panose="02070309020205020404" pitchFamily="49" charset="0"/>
+              </a:rPr>
+              <a:t> </a:t>
             </a:r>
             <a:r>
               <a:rPr lang="de-AT" sz="800" b="0" dirty="0">
                 <a:latin typeface="Courier New" panose="02070309020205020404" pitchFamily="49" charset="0"/>
                 <a:cs typeface="Courier New" panose="02070309020205020404" pitchFamily="49" charset="0"/>
               </a:rPr>
-              <a:t> , </a:t>
-            </a:r>
-            <a:r>
-              <a:rPr lang="de-AT" sz="800" b="0" dirty="0" err="1">
+              <a:t>, </a:t>
+            </a:r>
+            <a:r>
+              <a:rPr lang="de-AT" sz="800" b="0" dirty="0" err="1" smtClean="0">
                 <a:latin typeface="Courier New" panose="02070309020205020404" pitchFamily="49" charset="0"/>
                 <a:cs typeface="Courier New" panose="02070309020205020404" pitchFamily="49" charset="0"/>
               </a:rPr>
-              <a:t>n_uh_amax_lower</a:t>
+              <a:t>n_uh_amax</a:t>
+            </a:r>
+            <a:r>
+              <a:rPr lang="de-AT" sz="800" b="0" dirty="0" smtClean="0">
+                <a:latin typeface="Courier New" panose="02070309020205020404" pitchFamily="49" charset="0"/>
+                <a:cs typeface="Courier New" panose="02070309020205020404" pitchFamily="49" charset="0"/>
+              </a:rPr>
+              <a:t> </a:t>
             </a:r>
             <a:r>
               <a:rPr lang="de-AT" sz="800" b="0" dirty="0">
                 <a:latin typeface="Courier New" panose="02070309020205020404" pitchFamily="49" charset="0"/>
                 <a:cs typeface="Courier New" panose="02070309020205020404" pitchFamily="49" charset="0"/>
               </a:rPr>
-              <a:t> , </a:t>
-            </a:r>
-            <a:r>
-              <a:rPr lang="de-AT" sz="800" b="0" dirty="0" err="1">
+              <a:t>, </a:t>
+            </a:r>
+            <a:r>
+              <a:rPr lang="de-AT" sz="800" b="0" dirty="0" err="1" smtClean="0">
                 <a:latin typeface="Courier New" panose="02070309020205020404" pitchFamily="49" charset="0"/>
                 <a:cs typeface="Courier New" panose="02070309020205020404" pitchFamily="49" charset="0"/>
               </a:rPr>
-              <a:t>n_dh_amin_lower</a:t>
+              <a:t>n_dh_amin</a:t>
+            </a:r>
+            <a:r>
+              <a:rPr lang="de-AT" sz="800" b="0" dirty="0" smtClean="0">
+                <a:latin typeface="Courier New" panose="02070309020205020404" pitchFamily="49" charset="0"/>
+                <a:cs typeface="Courier New" panose="02070309020205020404" pitchFamily="49" charset="0"/>
+              </a:rPr>
+              <a:t> </a:t>
             </a:r>
             <a:r>
               <a:rPr lang="de-AT" sz="800" b="0" dirty="0">
                 <a:latin typeface="Courier New" panose="02070309020205020404" pitchFamily="49" charset="0"/>
                 <a:cs typeface="Courier New" panose="02070309020205020404" pitchFamily="49" charset="0"/>
               </a:rPr>
-              <a:t> , </a:t>
-            </a:r>
-            <a:r>
-              <a:rPr lang="de-AT" sz="800" b="0" dirty="0" err="1">
+              <a:t>, </a:t>
+            </a:r>
+            <a:r>
+              <a:rPr lang="de-AT" sz="800" b="0" dirty="0" err="1" smtClean="0">
                 <a:latin typeface="Courier New" panose="02070309020205020404" pitchFamily="49" charset="0"/>
                 <a:cs typeface="Courier New" panose="02070309020205020404" pitchFamily="49" charset="0"/>
               </a:rPr>
-              <a:t>n_level_amin_lower</a:t>
-            </a:r>
-            <a:r>
-              <a:rPr lang="de-AT" sz="800" b="0" dirty="0">
+              <a:t>n_level_amin</a:t>
+            </a:r>
+            <a:r>
+              <a:rPr lang="de-AT" sz="800" b="0" dirty="0" smtClean="0">
                 <a:latin typeface="Courier New" panose="02070309020205020404" pitchFamily="49" charset="0"/>
                 <a:cs typeface="Courier New" panose="02070309020205020404" pitchFamily="49" charset="0"/>
               </a:rPr>
               <a:t> , </a:t>
             </a:r>
             <a:r>
-              <a:rPr lang="de-AT" sz="800" b="0" dirty="0" err="1">
-                <a:latin typeface="Courier New" panose="02070309020205020404" pitchFamily="49" charset="0"/>
-                <a:cs typeface="Courier New" panose="02070309020205020404" pitchFamily="49" charset="0"/>
-              </a:rPr>
-              <a:t>n_uh_amin_lower</a:t>
-            </a:r>
-            <a:r>
-              <a:rPr lang="de-AT" sz="800" b="0" dirty="0">
-                <a:latin typeface="Courier New" panose="02070309020205020404" pitchFamily="49" charset="0"/>
-                <a:cs typeface="Courier New" panose="02070309020205020404" pitchFamily="49" charset="0"/>
-              </a:rPr>
-              <a:t> , </a:t>
-            </a:r>
-            <a:r>
-              <a:rPr lang="de-AT" sz="800" b="0" dirty="0" err="1">
-                <a:latin typeface="Courier New" panose="02070309020205020404" pitchFamily="49" charset="0"/>
-                <a:cs typeface="Courier New" panose="02070309020205020404" pitchFamily="49" charset="0"/>
-              </a:rPr>
-              <a:t>n_dh_amax_upper</a:t>
-            </a:r>
-            <a:r>
-              <a:rPr lang="de-AT" sz="800" b="0" dirty="0">
-                <a:latin typeface="Courier New" panose="02070309020205020404" pitchFamily="49" charset="0"/>
-                <a:cs typeface="Courier New" panose="02070309020205020404" pitchFamily="49" charset="0"/>
-              </a:rPr>
-              <a:t> , </a:t>
-            </a:r>
-            <a:r>
-              <a:rPr lang="de-AT" sz="800" b="0" dirty="0" err="1">
-                <a:latin typeface="Courier New" panose="02070309020205020404" pitchFamily="49" charset="0"/>
-                <a:cs typeface="Courier New" panose="02070309020205020404" pitchFamily="49" charset="0"/>
-              </a:rPr>
-              <a:t>n_level_amax_upper</a:t>
-            </a:r>
-            <a:r>
-              <a:rPr lang="de-AT" sz="800" b="0" dirty="0">
-                <a:latin typeface="Courier New" panose="02070309020205020404" pitchFamily="49" charset="0"/>
-                <a:cs typeface="Courier New" panose="02070309020205020404" pitchFamily="49" charset="0"/>
-              </a:rPr>
-              <a:t> , </a:t>
-            </a:r>
-            <a:r>
-              <a:rPr lang="de-AT" sz="800" b="0" dirty="0" err="1">
-                <a:latin typeface="Courier New" panose="02070309020205020404" pitchFamily="49" charset="0"/>
-                <a:cs typeface="Courier New" panose="02070309020205020404" pitchFamily="49" charset="0"/>
-              </a:rPr>
-              <a:t>n_uh_amax_upper</a:t>
-            </a:r>
-            <a:r>
-              <a:rPr lang="de-AT" sz="800" b="0" dirty="0">
-                <a:latin typeface="Courier New" panose="02070309020205020404" pitchFamily="49" charset="0"/>
-                <a:cs typeface="Courier New" panose="02070309020205020404" pitchFamily="49" charset="0"/>
-              </a:rPr>
-              <a:t> , </a:t>
-            </a:r>
-            <a:r>
-              <a:rPr lang="de-AT" sz="800" b="0" dirty="0" err="1">
-                <a:latin typeface="Courier New" panose="02070309020205020404" pitchFamily="49" charset="0"/>
-                <a:cs typeface="Courier New" panose="02070309020205020404" pitchFamily="49" charset="0"/>
-              </a:rPr>
-              <a:t>n_dh_amin_upper</a:t>
-            </a:r>
-            <a:r>
-              <a:rPr lang="de-AT" sz="800" b="0" dirty="0">
-                <a:latin typeface="Courier New" panose="02070309020205020404" pitchFamily="49" charset="0"/>
-                <a:cs typeface="Courier New" panose="02070309020205020404" pitchFamily="49" charset="0"/>
-              </a:rPr>
-              <a:t> , </a:t>
-            </a:r>
-            <a:r>
-              <a:rPr lang="de-AT" sz="800" b="0" dirty="0" err="1">
-                <a:latin typeface="Courier New" panose="02070309020205020404" pitchFamily="49" charset="0"/>
-                <a:cs typeface="Courier New" panose="02070309020205020404" pitchFamily="49" charset="0"/>
-              </a:rPr>
-              <a:t>n_level_amin_upper</a:t>
-            </a:r>
-            <a:r>
-              <a:rPr lang="de-AT" sz="800" b="0" dirty="0">
-                <a:latin typeface="Courier New" panose="02070309020205020404" pitchFamily="49" charset="0"/>
-                <a:cs typeface="Courier New" panose="02070309020205020404" pitchFamily="49" charset="0"/>
-              </a:rPr>
-              <a:t> , </a:t>
-            </a:r>
-            <a:r>
               <a:rPr lang="de-AT" sz="800" b="0" dirty="0" err="1" smtClean="0">
                 <a:latin typeface="Courier New" panose="02070309020205020404" pitchFamily="49" charset="0"/>
                 <a:cs typeface="Courier New" panose="02070309020205020404" pitchFamily="49" charset="0"/>
               </a:rPr>
-              <a:t>n_uh_amin_upper</a:t>
+              <a:t>n_uh_amin</a:t>
             </a:r>
             <a:endParaRPr lang="de-AT" sz="800" b="0" dirty="0" smtClean="0">
               <a:latin typeface="Courier New" panose="02070309020205020404" pitchFamily="49" charset="0"/>
@@ -6704,7 +6645,21 @@
                 <a:latin typeface="Courier New" panose="02070309020205020404" pitchFamily="49" charset="0"/>
                 <a:cs typeface="Courier New" panose="02070309020205020404" pitchFamily="49" charset="0"/>
               </a:rPr>
-              <a:t>, 4         , 650             , </a:t>
+              <a:t>, 4         , 650     </a:t>
+            </a:r>
+            <a:r>
+              <a:rPr lang="de-AT" sz="800" b="0" dirty="0" smtClean="0">
+                <a:latin typeface="Courier New" panose="02070309020205020404" pitchFamily="49" charset="0"/>
+                <a:cs typeface="Courier New" panose="02070309020205020404" pitchFamily="49" charset="0"/>
+              </a:rPr>
+              <a:t>  </a:t>
+            </a:r>
+            <a:r>
+              <a:rPr lang="de-AT" sz="800" b="0" dirty="0">
+                <a:latin typeface="Courier New" panose="02070309020205020404" pitchFamily="49" charset="0"/>
+                <a:cs typeface="Courier New" panose="02070309020205020404" pitchFamily="49" charset="0"/>
+              </a:rPr>
+              <a:t>, </a:t>
             </a:r>
             <a:r>
               <a:rPr lang="de-AT" sz="800" b="0" dirty="0">
@@ -6721,7 +6676,42 @@
                 <a:latin typeface="Courier New" panose="02070309020205020404" pitchFamily="49" charset="0"/>
                 <a:cs typeface="Courier New" panose="02070309020205020404" pitchFamily="49" charset="0"/>
               </a:rPr>
-              <a:t>                , 725             , 670             , </a:t>
+              <a:t>         </a:t>
+            </a:r>
+            <a:r>
+              <a:rPr lang="de-AT" sz="800" b="0" dirty="0" smtClean="0">
+                <a:latin typeface="Courier New" panose="02070309020205020404" pitchFamily="49" charset="0"/>
+                <a:cs typeface="Courier New" panose="02070309020205020404" pitchFamily="49" charset="0"/>
+              </a:rPr>
+              <a:t> </a:t>
+            </a:r>
+            <a:r>
+              <a:rPr lang="de-AT" sz="800" b="0" dirty="0">
+                <a:latin typeface="Courier New" panose="02070309020205020404" pitchFamily="49" charset="0"/>
+                <a:cs typeface="Courier New" panose="02070309020205020404" pitchFamily="49" charset="0"/>
+              </a:rPr>
+              <a:t>, 725       </a:t>
+            </a:r>
+            <a:r>
+              <a:rPr lang="de-AT" sz="800" b="0" dirty="0" smtClean="0">
+                <a:latin typeface="Courier New" panose="02070309020205020404" pitchFamily="49" charset="0"/>
+                <a:cs typeface="Courier New" panose="02070309020205020404" pitchFamily="49" charset="0"/>
+              </a:rPr>
+              <a:t>, </a:t>
+            </a:r>
+            <a:r>
+              <a:rPr lang="de-AT" sz="800" b="0" dirty="0">
+                <a:latin typeface="Courier New" panose="02070309020205020404" pitchFamily="49" charset="0"/>
+                <a:cs typeface="Courier New" panose="02070309020205020404" pitchFamily="49" charset="0"/>
+              </a:rPr>
+              <a:t>670       </a:t>
+            </a:r>
+            <a:r>
+              <a:rPr lang="de-AT" sz="800" b="0" dirty="0" smtClean="0">
+                <a:latin typeface="Courier New" panose="02070309020205020404" pitchFamily="49" charset="0"/>
+                <a:cs typeface="Courier New" panose="02070309020205020404" pitchFamily="49" charset="0"/>
+              </a:rPr>
+              <a:t>, </a:t>
             </a:r>
             <a:r>
               <a:rPr lang="de-AT" sz="800" b="0" dirty="0">
@@ -6738,7 +6728,28 @@
                 <a:latin typeface="Courier New" panose="02070309020205020404" pitchFamily="49" charset="0"/>
                 <a:cs typeface="Courier New" panose="02070309020205020404" pitchFamily="49" charset="0"/>
               </a:rPr>
-              <a:t>                , 745             ,                 ,                    ,                 ,                 ,                    ,</a:t>
+              <a:t>          </a:t>
+            </a:r>
+            <a:r>
+              <a:rPr lang="de-AT" sz="800" b="0" dirty="0" smtClean="0">
+                <a:latin typeface="Courier New" panose="02070309020205020404" pitchFamily="49" charset="0"/>
+                <a:cs typeface="Courier New" panose="02070309020205020404" pitchFamily="49" charset="0"/>
+              </a:rPr>
+              <a:t> </a:t>
+            </a:r>
+            <a:r>
+              <a:rPr lang="de-AT" sz="800" b="0" dirty="0">
+                <a:latin typeface="Courier New" panose="02070309020205020404" pitchFamily="49" charset="0"/>
+                <a:cs typeface="Courier New" panose="02070309020205020404" pitchFamily="49" charset="0"/>
+              </a:rPr>
+              <a:t>, </a:t>
+            </a:r>
+            <a:r>
+              <a:rPr lang="de-AT" sz="800" b="0" dirty="0" smtClean="0">
+                <a:latin typeface="Courier New" panose="02070309020205020404" pitchFamily="49" charset="0"/>
+                <a:cs typeface="Courier New" panose="02070309020205020404" pitchFamily="49" charset="0"/>
+              </a:rPr>
+              <a:t>745             </a:t>
             </a:r>
           </a:p>
           <a:p>
@@ -7497,1481 +7508,6 @@
             <p:ph type="title"/>
           </p:nvPr>
         </p:nvSpPr>
-        <p:spPr>
-          <a:xfrm>
-            <a:off x="468315" y="476672"/>
-            <a:ext cx="8218487" cy="681038"/>
-          </a:xfrm>
-        </p:spPr>
-        <p:txBody>
-          <a:bodyPr/>
-          <a:lstStyle/>
-          <a:p>
-            <a:r>
-              <a:rPr lang="en-US" dirty="0" err="1" smtClean="0"/>
-              <a:t>Voith</a:t>
-            </a:r>
-            <a:r>
-              <a:rPr lang="en-US" dirty="0" smtClean="0"/>
-              <a:t> AT Gearshift Strategy</a:t>
-            </a:r>
-            <a:endParaRPr lang="en-US" sz="1600" dirty="0"/>
-          </a:p>
-        </p:txBody>
-      </p:sp>
-      <p:sp>
-        <p:nvSpPr>
-          <p:cNvPr id="3" name="Inhaltsplatzhalter 2"/>
-          <p:cNvSpPr>
-            <a:spLocks noGrp="1"/>
-          </p:cNvSpPr>
-          <p:nvPr>
-            <p:ph idx="1"/>
-          </p:nvPr>
-        </p:nvSpPr>
-        <p:spPr>
-          <a:xfrm>
-            <a:off x="323529" y="1628800"/>
-            <a:ext cx="8640960" cy="1152128"/>
-          </a:xfrm>
-        </p:spPr>
-        <p:txBody>
-          <a:bodyPr/>
-          <a:lstStyle/>
-          <a:p>
-            <a:r>
-              <a:rPr lang="en-US" sz="1600" dirty="0" err="1" smtClean="0"/>
-              <a:t>LoadStageShiftLines</a:t>
-            </a:r>
-            <a:r>
-              <a:rPr lang="en-US" sz="1600" dirty="0" smtClean="0"/>
-              <a:t>: Example upshift 1 -&gt; 2, load stage 5</a:t>
-            </a:r>
-            <a:endParaRPr lang="en-US" sz="1000" dirty="0" smtClean="0"/>
-          </a:p>
-        </p:txBody>
-      </p:sp>
-      <p:sp>
-        <p:nvSpPr>
-          <p:cNvPr id="5" name="Rechteck 4"/>
-          <p:cNvSpPr/>
-          <p:nvPr/>
-        </p:nvSpPr>
-        <p:spPr>
-          <a:xfrm>
-            <a:off x="468314" y="2057653"/>
-            <a:ext cx="15624965" cy="769441"/>
-          </a:xfrm>
-          <a:prstGeom prst="rect">
-            <a:avLst/>
-          </a:prstGeom>
-        </p:spPr>
-        <p:txBody>
-          <a:bodyPr wrap="square">
-            <a:spAutoFit/>
-          </a:bodyPr>
-          <a:lstStyle/>
-          <a:p>
-            <a:pPr algn="l"/>
-            <a:r>
-              <a:rPr lang="en-US" sz="800" b="0" dirty="0" smtClean="0">
-                <a:latin typeface="Courier New" panose="02070309020205020404" pitchFamily="49" charset="0"/>
-                <a:cs typeface="Courier New" panose="02070309020205020404" pitchFamily="49" charset="0"/>
-              </a:rPr>
-              <a:t>…</a:t>
-            </a:r>
-            <a:r>
-              <a:rPr lang="de-AT" sz="800" b="0" dirty="0" err="1">
-                <a:latin typeface="Courier New" panose="02070309020205020404" pitchFamily="49" charset="0"/>
-                <a:cs typeface="Courier New" panose="02070309020205020404" pitchFamily="49" charset="0"/>
-              </a:rPr>
-              <a:t>shift</a:t>
-            </a:r>
-            <a:r>
-              <a:rPr lang="de-AT" sz="800" b="0" dirty="0">
-                <a:latin typeface="Courier New" panose="02070309020205020404" pitchFamily="49" charset="0"/>
-                <a:cs typeface="Courier New" panose="02070309020205020404" pitchFamily="49" charset="0"/>
-              </a:rPr>
-              <a:t> , </a:t>
-            </a:r>
-            <a:r>
-              <a:rPr lang="de-AT" sz="800" b="0" dirty="0" err="1">
-                <a:latin typeface="Courier New" panose="02070309020205020404" pitchFamily="49" charset="0"/>
-                <a:cs typeface="Courier New" panose="02070309020205020404" pitchFamily="49" charset="0"/>
-              </a:rPr>
-              <a:t>LoadStage</a:t>
-            </a:r>
-            <a:r>
-              <a:rPr lang="de-AT" sz="800" b="0" dirty="0">
-                <a:latin typeface="Courier New" panose="02070309020205020404" pitchFamily="49" charset="0"/>
-                <a:cs typeface="Courier New" panose="02070309020205020404" pitchFamily="49" charset="0"/>
-              </a:rPr>
-              <a:t> </a:t>
-            </a:r>
-            <a:r>
-              <a:rPr lang="de-AT" sz="800" b="0" dirty="0" smtClean="0">
-                <a:latin typeface="Courier New" panose="02070309020205020404" pitchFamily="49" charset="0"/>
-                <a:cs typeface="Courier New" panose="02070309020205020404" pitchFamily="49" charset="0"/>
-              </a:rPr>
-              <a:t>,[…], </a:t>
-            </a:r>
-            <a:r>
-              <a:rPr lang="de-AT" sz="800" b="0" dirty="0" err="1">
-                <a:latin typeface="Courier New" panose="02070309020205020404" pitchFamily="49" charset="0"/>
-                <a:cs typeface="Courier New" panose="02070309020205020404" pitchFamily="49" charset="0"/>
-              </a:rPr>
-              <a:t>n_level_amax_lower</a:t>
-            </a:r>
-            <a:r>
-              <a:rPr lang="de-AT" sz="800" b="0" dirty="0">
-                <a:latin typeface="Courier New" panose="02070309020205020404" pitchFamily="49" charset="0"/>
-                <a:cs typeface="Courier New" panose="02070309020205020404" pitchFamily="49" charset="0"/>
-              </a:rPr>
-              <a:t> , […], </a:t>
-            </a:r>
-            <a:r>
-              <a:rPr lang="de-AT" sz="800" b="0" dirty="0" err="1">
-                <a:latin typeface="Courier New" panose="02070309020205020404" pitchFamily="49" charset="0"/>
-                <a:cs typeface="Courier New" panose="02070309020205020404" pitchFamily="49" charset="0"/>
-              </a:rPr>
-              <a:t>n_level_amin_lower</a:t>
-            </a:r>
-            <a:r>
-              <a:rPr lang="de-AT" sz="800" b="0" dirty="0">
-                <a:latin typeface="Courier New" panose="02070309020205020404" pitchFamily="49" charset="0"/>
-                <a:cs typeface="Courier New" panose="02070309020205020404" pitchFamily="49" charset="0"/>
-              </a:rPr>
-              <a:t> , […]</a:t>
-            </a:r>
-            <a:r>
-              <a:rPr lang="de-AT" sz="800" b="0" dirty="0" smtClean="0">
-                <a:latin typeface="Courier New" panose="02070309020205020404" pitchFamily="49" charset="0"/>
-                <a:cs typeface="Courier New" panose="02070309020205020404" pitchFamily="49" charset="0"/>
-              </a:rPr>
-              <a:t>, </a:t>
-            </a:r>
-            <a:r>
-              <a:rPr lang="de-AT" sz="800" b="0" dirty="0" err="1">
-                <a:latin typeface="Courier New" panose="02070309020205020404" pitchFamily="49" charset="0"/>
-                <a:cs typeface="Courier New" panose="02070309020205020404" pitchFamily="49" charset="0"/>
-              </a:rPr>
-              <a:t>n_level_amax_upper</a:t>
-            </a:r>
-            <a:r>
-              <a:rPr lang="de-AT" sz="800" b="0" dirty="0">
-                <a:latin typeface="Courier New" panose="02070309020205020404" pitchFamily="49" charset="0"/>
-                <a:cs typeface="Courier New" panose="02070309020205020404" pitchFamily="49" charset="0"/>
-              </a:rPr>
-              <a:t> , […]</a:t>
-            </a:r>
-            <a:r>
-              <a:rPr lang="de-AT" sz="800" b="0" dirty="0" smtClean="0">
-                <a:latin typeface="Courier New" panose="02070309020205020404" pitchFamily="49" charset="0"/>
-                <a:cs typeface="Courier New" panose="02070309020205020404" pitchFamily="49" charset="0"/>
-              </a:rPr>
-              <a:t>, </a:t>
-            </a:r>
-            <a:r>
-              <a:rPr lang="de-AT" sz="800" b="0" dirty="0" err="1">
-                <a:latin typeface="Courier New" panose="02070309020205020404" pitchFamily="49" charset="0"/>
-                <a:cs typeface="Courier New" panose="02070309020205020404" pitchFamily="49" charset="0"/>
-              </a:rPr>
-              <a:t>n_level_amin_upper</a:t>
-            </a:r>
-            <a:r>
-              <a:rPr lang="de-AT" sz="800" b="0" dirty="0">
-                <a:latin typeface="Courier New" panose="02070309020205020404" pitchFamily="49" charset="0"/>
-                <a:cs typeface="Courier New" panose="02070309020205020404" pitchFamily="49" charset="0"/>
-              </a:rPr>
-              <a:t> </a:t>
-            </a:r>
-            <a:r>
-              <a:rPr lang="de-AT" sz="800" b="0" dirty="0" smtClean="0">
-                <a:latin typeface="Courier New" panose="02070309020205020404" pitchFamily="49" charset="0"/>
-                <a:cs typeface="Courier New" panose="02070309020205020404" pitchFamily="49" charset="0"/>
-              </a:rPr>
-              <a:t>,</a:t>
-            </a:r>
-            <a:r>
-              <a:rPr lang="de-AT" sz="800" b="0" dirty="0">
-                <a:latin typeface="Courier New" panose="02070309020205020404" pitchFamily="49" charset="0"/>
-                <a:cs typeface="Courier New" panose="02070309020205020404" pitchFamily="49" charset="0"/>
-              </a:rPr>
-              <a:t> […]</a:t>
-            </a:r>
-            <a:r>
-              <a:rPr lang="de-AT" sz="800" b="0" dirty="0" smtClean="0">
-                <a:latin typeface="Courier New" panose="02070309020205020404" pitchFamily="49" charset="0"/>
-                <a:cs typeface="Courier New" panose="02070309020205020404" pitchFamily="49" charset="0"/>
-              </a:rPr>
-              <a:t> </a:t>
-            </a:r>
-            <a:endParaRPr lang="de-AT" sz="800" b="0" dirty="0">
-              <a:latin typeface="Courier New" panose="02070309020205020404" pitchFamily="49" charset="0"/>
-              <a:cs typeface="Courier New" panose="02070309020205020404" pitchFamily="49" charset="0"/>
-            </a:endParaRPr>
-          </a:p>
-          <a:p>
-            <a:pPr algn="l"/>
-            <a:endParaRPr lang="de-AT" sz="800" b="0" dirty="0" smtClean="0">
-              <a:latin typeface="Courier New" panose="02070309020205020404" pitchFamily="49" charset="0"/>
-              <a:cs typeface="Courier New" panose="02070309020205020404" pitchFamily="49" charset="0"/>
-            </a:endParaRPr>
-          </a:p>
-          <a:p>
-            <a:pPr algn="l"/>
-            <a:r>
-              <a:rPr lang="de-AT" sz="800" b="0" dirty="0" smtClean="0">
-                <a:latin typeface="Courier New" panose="02070309020205020404" pitchFamily="49" charset="0"/>
-                <a:cs typeface="Courier New" panose="02070309020205020404" pitchFamily="49" charset="0"/>
-              </a:rPr>
-              <a:t>1-2   </a:t>
-            </a:r>
-            <a:r>
-              <a:rPr lang="de-AT" sz="800" b="0" dirty="0">
-                <a:latin typeface="Courier New" panose="02070309020205020404" pitchFamily="49" charset="0"/>
-                <a:cs typeface="Courier New" panose="02070309020205020404" pitchFamily="49" charset="0"/>
-              </a:rPr>
-              <a:t>, 5         , </a:t>
-            </a:r>
-            <a:r>
-              <a:rPr lang="de-AT" sz="800" b="0" dirty="0" smtClean="0">
-                <a:latin typeface="Courier New" panose="02070309020205020404" pitchFamily="49" charset="0"/>
-                <a:cs typeface="Courier New" panose="02070309020205020404" pitchFamily="49" charset="0"/>
-              </a:rPr>
-              <a:t>[…], </a:t>
-            </a:r>
-            <a:r>
-              <a:rPr lang="de-AT" sz="800" b="0" dirty="0">
-                <a:solidFill>
-                  <a:srgbClr val="FF0000"/>
-                </a:solidFill>
-                <a:latin typeface="Courier New" panose="02070309020205020404" pitchFamily="49" charset="0"/>
-                <a:cs typeface="Courier New" panose="02070309020205020404" pitchFamily="49" charset="0"/>
-              </a:rPr>
-              <a:t>680</a:t>
-            </a:r>
-            <a:r>
-              <a:rPr lang="de-AT" sz="800" b="0" dirty="0">
-                <a:latin typeface="Courier New" panose="02070309020205020404" pitchFamily="49" charset="0"/>
-                <a:cs typeface="Courier New" panose="02070309020205020404" pitchFamily="49" charset="0"/>
-              </a:rPr>
-              <a:t>                , </a:t>
-            </a:r>
-            <a:r>
-              <a:rPr lang="de-AT" sz="800" b="0" dirty="0" smtClean="0">
-                <a:latin typeface="Courier New" panose="02070309020205020404" pitchFamily="49" charset="0"/>
-                <a:cs typeface="Courier New" panose="02070309020205020404" pitchFamily="49" charset="0"/>
-              </a:rPr>
-              <a:t>[…], </a:t>
-            </a:r>
-            <a:r>
-              <a:rPr lang="de-AT" sz="800" b="0" dirty="0">
-                <a:solidFill>
-                  <a:srgbClr val="FF0000"/>
-                </a:solidFill>
-                <a:latin typeface="Courier New" panose="02070309020205020404" pitchFamily="49" charset="0"/>
-                <a:cs typeface="Courier New" panose="02070309020205020404" pitchFamily="49" charset="0"/>
-              </a:rPr>
-              <a:t>700</a:t>
-            </a:r>
-            <a:r>
-              <a:rPr lang="de-AT" sz="800" b="0" dirty="0">
-                <a:latin typeface="Courier New" panose="02070309020205020404" pitchFamily="49" charset="0"/>
-                <a:cs typeface="Courier New" panose="02070309020205020404" pitchFamily="49" charset="0"/>
-              </a:rPr>
-              <a:t>                , […]</a:t>
-            </a:r>
-            <a:r>
-              <a:rPr lang="de-AT" sz="800" b="0" dirty="0" smtClean="0">
-                <a:latin typeface="Courier New" panose="02070309020205020404" pitchFamily="49" charset="0"/>
-                <a:cs typeface="Courier New" panose="02070309020205020404" pitchFamily="49" charset="0"/>
-              </a:rPr>
-              <a:t>, </a:t>
-            </a:r>
-            <a:r>
-              <a:rPr lang="de-AT" sz="800" b="0" dirty="0">
-                <a:solidFill>
-                  <a:srgbClr val="0066FF"/>
-                </a:solidFill>
-                <a:latin typeface="Courier New" panose="02070309020205020404" pitchFamily="49" charset="0"/>
-                <a:cs typeface="Courier New" panose="02070309020205020404" pitchFamily="49" charset="0"/>
-              </a:rPr>
-              <a:t>700</a:t>
-            </a:r>
-            <a:r>
-              <a:rPr lang="de-AT" sz="800" b="0" dirty="0">
-                <a:latin typeface="Courier New" panose="02070309020205020404" pitchFamily="49" charset="0"/>
-                <a:cs typeface="Courier New" panose="02070309020205020404" pitchFamily="49" charset="0"/>
-              </a:rPr>
-              <a:t>                , […]</a:t>
-            </a:r>
-            <a:r>
-              <a:rPr lang="de-AT" sz="800" b="0" dirty="0" smtClean="0">
-                <a:latin typeface="Courier New" panose="02070309020205020404" pitchFamily="49" charset="0"/>
-                <a:cs typeface="Courier New" panose="02070309020205020404" pitchFamily="49" charset="0"/>
-              </a:rPr>
-              <a:t>, </a:t>
-            </a:r>
-            <a:r>
-              <a:rPr lang="de-AT" sz="800" b="0" dirty="0">
-                <a:solidFill>
-                  <a:srgbClr val="0066FF"/>
-                </a:solidFill>
-                <a:latin typeface="Courier New" panose="02070309020205020404" pitchFamily="49" charset="0"/>
-                <a:cs typeface="Courier New" panose="02070309020205020404" pitchFamily="49" charset="0"/>
-              </a:rPr>
-              <a:t>720</a:t>
-            </a:r>
-            <a:r>
-              <a:rPr lang="de-AT" sz="800" b="0" dirty="0">
-                <a:latin typeface="Courier New" panose="02070309020205020404" pitchFamily="49" charset="0"/>
-                <a:cs typeface="Courier New" panose="02070309020205020404" pitchFamily="49" charset="0"/>
-              </a:rPr>
-              <a:t>                </a:t>
-            </a:r>
-            <a:r>
-              <a:rPr lang="de-AT" sz="800" b="0" dirty="0" smtClean="0">
-                <a:latin typeface="Courier New" panose="02070309020205020404" pitchFamily="49" charset="0"/>
-                <a:cs typeface="Courier New" panose="02070309020205020404" pitchFamily="49" charset="0"/>
-              </a:rPr>
-              <a:t>,</a:t>
-            </a:r>
-            <a:r>
-              <a:rPr lang="de-AT" sz="800" b="0" dirty="0">
-                <a:latin typeface="Courier New" panose="02070309020205020404" pitchFamily="49" charset="0"/>
-                <a:cs typeface="Courier New" panose="02070309020205020404" pitchFamily="49" charset="0"/>
-              </a:rPr>
-              <a:t> […]</a:t>
-            </a:r>
-            <a:r>
-              <a:rPr lang="de-AT" sz="800" b="0" dirty="0" smtClean="0">
-                <a:latin typeface="Courier New" panose="02070309020205020404" pitchFamily="49" charset="0"/>
-                <a:cs typeface="Courier New" panose="02070309020205020404" pitchFamily="49" charset="0"/>
-              </a:rPr>
-              <a:t> </a:t>
-            </a:r>
-          </a:p>
-          <a:p>
-            <a:pPr algn="l"/>
-            <a:r>
-              <a:rPr lang="en-US" sz="800" b="0" dirty="0" smtClean="0">
-                <a:latin typeface="Courier New" panose="02070309020205020404" pitchFamily="49" charset="0"/>
-                <a:cs typeface="Courier New" panose="02070309020205020404" pitchFamily="49" charset="0"/>
-              </a:rPr>
-              <a:t>…</a:t>
-            </a:r>
-            <a:endParaRPr lang="de-AT" sz="800" b="0" dirty="0">
-              <a:latin typeface="Courier New" panose="02070309020205020404" pitchFamily="49" charset="0"/>
-              <a:cs typeface="Courier New" panose="02070309020205020404" pitchFamily="49" charset="0"/>
-            </a:endParaRPr>
-          </a:p>
-        </p:txBody>
-      </p:sp>
-      <p:grpSp>
-        <p:nvGrpSpPr>
-          <p:cNvPr id="6" name="Gruppieren 5"/>
-          <p:cNvGrpSpPr/>
-          <p:nvPr/>
-        </p:nvGrpSpPr>
-        <p:grpSpPr>
-          <a:xfrm>
-            <a:off x="1978005" y="2879804"/>
-            <a:ext cx="5654133" cy="3496878"/>
-            <a:chOff x="1978005" y="2879804"/>
-            <a:chExt cx="5654133" cy="3496878"/>
-          </a:xfrm>
-        </p:grpSpPr>
-        <p:cxnSp>
-          <p:nvCxnSpPr>
-            <p:cNvPr id="7" name="Gerade Verbindung mit Pfeil 6"/>
-            <p:cNvCxnSpPr/>
-            <p:nvPr/>
-          </p:nvCxnSpPr>
-          <p:spPr bwMode="auto">
-            <a:xfrm>
-              <a:off x="2447764" y="5949280"/>
-              <a:ext cx="5004556" cy="0"/>
-            </a:xfrm>
-            <a:prstGeom prst="straightConnector1">
-              <a:avLst/>
-            </a:prstGeom>
-            <a:solidFill>
-              <a:schemeClr val="accent1"/>
-            </a:solidFill>
-            <a:ln w="12700" cap="flat" cmpd="sng" algn="ctr">
-              <a:solidFill>
-                <a:schemeClr val="tx1"/>
-              </a:solidFill>
-              <a:prstDash val="solid"/>
-              <a:round/>
-              <a:headEnd type="none" w="med" len="med"/>
-              <a:tailEnd type="triangle"/>
-            </a:ln>
-            <a:effectLst/>
-            <a:extLst>
-              <a:ext uri="{AF507438-7753-43E0-B8FC-AC1667EBCBE1}">
-                <a14:hiddenEffects xmlns:a14="http://schemas.microsoft.com/office/drawing/2010/main">
-                  <a:effectLst>
-                    <a:outerShdw dist="35921" dir="2700000" algn="ctr" rotWithShape="0">
-                      <a:schemeClr val="bg2"/>
-                    </a:outerShdw>
-                  </a:effectLst>
-                </a14:hiddenEffects>
-              </a:ext>
-            </a:extLst>
-          </p:spPr>
-        </p:cxnSp>
-        <p:cxnSp>
-          <p:nvCxnSpPr>
-            <p:cNvPr id="8" name="Gerade Verbindung mit Pfeil 7"/>
-            <p:cNvCxnSpPr/>
-            <p:nvPr/>
-          </p:nvCxnSpPr>
-          <p:spPr bwMode="auto">
-            <a:xfrm flipV="1">
-              <a:off x="2627784" y="3140968"/>
-              <a:ext cx="0" cy="2952328"/>
-            </a:xfrm>
-            <a:prstGeom prst="straightConnector1">
-              <a:avLst/>
-            </a:prstGeom>
-            <a:solidFill>
-              <a:schemeClr val="accent1"/>
-            </a:solidFill>
-            <a:ln w="12700" cap="flat" cmpd="sng" algn="ctr">
-              <a:solidFill>
-                <a:schemeClr val="tx1"/>
-              </a:solidFill>
-              <a:prstDash val="solid"/>
-              <a:round/>
-              <a:headEnd type="none" w="med" len="med"/>
-              <a:tailEnd type="triangle"/>
-            </a:ln>
-            <a:effectLst/>
-            <a:extLst>
-              <a:ext uri="{AF507438-7753-43E0-B8FC-AC1667EBCBE1}">
-                <a14:hiddenEffects xmlns:a14="http://schemas.microsoft.com/office/drawing/2010/main">
-                  <a:effectLst>
-                    <a:outerShdw dist="35921" dir="2700000" algn="ctr" rotWithShape="0">
-                      <a:schemeClr val="bg2"/>
-                    </a:outerShdw>
-                  </a:effectLst>
-                </a14:hiddenEffects>
-              </a:ext>
-            </a:extLst>
-          </p:spPr>
-        </p:cxnSp>
-        <p:cxnSp>
-          <p:nvCxnSpPr>
-            <p:cNvPr id="9" name="Gerader Verbinder 8"/>
-            <p:cNvCxnSpPr/>
-            <p:nvPr/>
-          </p:nvCxnSpPr>
-          <p:spPr bwMode="auto">
-            <a:xfrm>
-              <a:off x="2555776" y="5373216"/>
-              <a:ext cx="144016" cy="0"/>
-            </a:xfrm>
-            <a:prstGeom prst="line">
-              <a:avLst/>
-            </a:prstGeom>
-            <a:solidFill>
-              <a:schemeClr val="accent1"/>
-            </a:solidFill>
-            <a:ln w="12700" cap="flat" cmpd="sng" algn="ctr">
-              <a:solidFill>
-                <a:schemeClr val="tx1"/>
-              </a:solidFill>
-              <a:prstDash val="solid"/>
-              <a:round/>
-              <a:headEnd type="none" w="med" len="med"/>
-              <a:tailEnd type="none" w="med" len="med"/>
-            </a:ln>
-            <a:effectLst/>
-            <a:extLst>
-              <a:ext uri="{AF507438-7753-43E0-B8FC-AC1667EBCBE1}">
-                <a14:hiddenEffects xmlns:a14="http://schemas.microsoft.com/office/drawing/2010/main">
-                  <a:effectLst>
-                    <a:outerShdw dist="35921" dir="2700000" algn="ctr" rotWithShape="0">
-                      <a:schemeClr val="bg2"/>
-                    </a:outerShdw>
-                  </a:effectLst>
-                </a14:hiddenEffects>
-              </a:ext>
-            </a:extLst>
-          </p:spPr>
-        </p:cxnSp>
-        <p:cxnSp>
-          <p:nvCxnSpPr>
-            <p:cNvPr id="10" name="Gerader Verbinder 9"/>
-            <p:cNvCxnSpPr/>
-            <p:nvPr/>
-          </p:nvCxnSpPr>
-          <p:spPr bwMode="auto">
-            <a:xfrm>
-              <a:off x="2555776" y="4077072"/>
-              <a:ext cx="144016" cy="0"/>
-            </a:xfrm>
-            <a:prstGeom prst="line">
-              <a:avLst/>
-            </a:prstGeom>
-            <a:solidFill>
-              <a:schemeClr val="accent1"/>
-            </a:solidFill>
-            <a:ln w="12700" cap="flat" cmpd="sng" algn="ctr">
-              <a:solidFill>
-                <a:schemeClr val="tx1"/>
-              </a:solidFill>
-              <a:prstDash val="solid"/>
-              <a:round/>
-              <a:headEnd type="none" w="med" len="med"/>
-              <a:tailEnd type="none" w="med" len="med"/>
-            </a:ln>
-            <a:effectLst/>
-            <a:extLst>
-              <a:ext uri="{AF507438-7753-43E0-B8FC-AC1667EBCBE1}">
-                <a14:hiddenEffects xmlns:a14="http://schemas.microsoft.com/office/drawing/2010/main">
-                  <a:effectLst>
-                    <a:outerShdw dist="35921" dir="2700000" algn="ctr" rotWithShape="0">
-                      <a:schemeClr val="bg2"/>
-                    </a:outerShdw>
-                  </a:effectLst>
-                </a14:hiddenEffects>
-              </a:ext>
-            </a:extLst>
-          </p:spPr>
-        </p:cxnSp>
-        <p:cxnSp>
-          <p:nvCxnSpPr>
-            <p:cNvPr id="11" name="Gerader Verbinder 10"/>
-            <p:cNvCxnSpPr/>
-            <p:nvPr/>
-          </p:nvCxnSpPr>
-          <p:spPr bwMode="auto">
-            <a:xfrm>
-              <a:off x="4067944" y="5877272"/>
-              <a:ext cx="0" cy="144016"/>
-            </a:xfrm>
-            <a:prstGeom prst="line">
-              <a:avLst/>
-            </a:prstGeom>
-            <a:solidFill>
-              <a:schemeClr val="accent1"/>
-            </a:solidFill>
-            <a:ln w="12700" cap="flat" cmpd="sng" algn="ctr">
-              <a:solidFill>
-                <a:schemeClr val="tx1"/>
-              </a:solidFill>
-              <a:prstDash val="solid"/>
-              <a:round/>
-              <a:headEnd type="none" w="med" len="med"/>
-              <a:tailEnd type="none" w="med" len="med"/>
-            </a:ln>
-            <a:effectLst/>
-            <a:extLst>
-              <a:ext uri="{AF507438-7753-43E0-B8FC-AC1667EBCBE1}">
-                <a14:hiddenEffects xmlns:a14="http://schemas.microsoft.com/office/drawing/2010/main">
-                  <a:effectLst>
-                    <a:outerShdw dist="35921" dir="2700000" algn="ctr" rotWithShape="0">
-                      <a:schemeClr val="bg2"/>
-                    </a:outerShdw>
-                  </a:effectLst>
-                </a14:hiddenEffects>
-              </a:ext>
-            </a:extLst>
-          </p:spPr>
-        </p:cxnSp>
-        <p:sp>
-          <p:nvSpPr>
-            <p:cNvPr id="12" name="Textfeld 11"/>
-            <p:cNvSpPr txBox="1"/>
-            <p:nvPr/>
-          </p:nvSpPr>
-          <p:spPr>
-            <a:xfrm>
-              <a:off x="2314878" y="2879804"/>
-              <a:ext cx="312906" cy="369332"/>
-            </a:xfrm>
-            <a:prstGeom prst="rect">
-              <a:avLst/>
-            </a:prstGeom>
-            <a:noFill/>
-            <a:ln>
-              <a:noFill/>
-            </a:ln>
-          </p:spPr>
-          <p:txBody>
-            <a:bodyPr wrap="none" rtlCol="0">
-              <a:spAutoFit/>
-            </a:bodyPr>
-            <a:lstStyle/>
-            <a:p>
-              <a:pPr algn="l">
-                <a:spcBef>
-                  <a:spcPts val="0"/>
-                </a:spcBef>
-              </a:pPr>
-              <a:r>
-                <a:rPr lang="en-US" sz="1800" b="0" dirty="0" smtClean="0"/>
-                <a:t>a</a:t>
-              </a:r>
-              <a:endParaRPr lang="de-AT" sz="1800" b="0" dirty="0" err="1" smtClean="0"/>
-            </a:p>
-          </p:txBody>
-        </p:sp>
-        <p:sp>
-          <p:nvSpPr>
-            <p:cNvPr id="13" name="Textfeld 12"/>
-            <p:cNvSpPr txBox="1"/>
-            <p:nvPr/>
-          </p:nvSpPr>
-          <p:spPr>
-            <a:xfrm>
-              <a:off x="7319232" y="5949280"/>
-              <a:ext cx="312906" cy="369332"/>
-            </a:xfrm>
-            <a:prstGeom prst="rect">
-              <a:avLst/>
-            </a:prstGeom>
-            <a:noFill/>
-            <a:ln>
-              <a:noFill/>
-            </a:ln>
-          </p:spPr>
-          <p:txBody>
-            <a:bodyPr wrap="none" rtlCol="0">
-              <a:spAutoFit/>
-            </a:bodyPr>
-            <a:lstStyle/>
-            <a:p>
-              <a:pPr algn="l">
-                <a:spcBef>
-                  <a:spcPts val="0"/>
-                </a:spcBef>
-              </a:pPr>
-              <a:r>
-                <a:rPr lang="en-US" sz="1800" b="0" dirty="0" smtClean="0"/>
-                <a:t>n</a:t>
-              </a:r>
-              <a:endParaRPr lang="de-AT" sz="1800" b="0" dirty="0" err="1" smtClean="0"/>
-            </a:p>
-          </p:txBody>
-        </p:sp>
-        <p:sp>
-          <p:nvSpPr>
-            <p:cNvPr id="14" name="Textfeld 13"/>
-            <p:cNvSpPr txBox="1"/>
-            <p:nvPr/>
-          </p:nvSpPr>
-          <p:spPr>
-            <a:xfrm>
-              <a:off x="2032011" y="5129274"/>
-              <a:ext cx="559769" cy="369332"/>
-            </a:xfrm>
-            <a:prstGeom prst="rect">
-              <a:avLst/>
-            </a:prstGeom>
-            <a:noFill/>
-            <a:ln>
-              <a:noFill/>
-            </a:ln>
-          </p:spPr>
-          <p:txBody>
-            <a:bodyPr wrap="none" rtlCol="0">
-              <a:spAutoFit/>
-            </a:bodyPr>
-            <a:lstStyle/>
-            <a:p>
-              <a:pPr algn="l">
-                <a:spcBef>
-                  <a:spcPts val="0"/>
-                </a:spcBef>
-              </a:pPr>
-              <a:r>
-                <a:rPr lang="en-US" sz="1800" b="0" dirty="0" err="1" smtClean="0"/>
-                <a:t>a</a:t>
-              </a:r>
-              <a:r>
-                <a:rPr lang="en-US" sz="1800" b="0" baseline="-25000" dirty="0" err="1" smtClean="0"/>
-                <a:t>min</a:t>
-              </a:r>
-              <a:endParaRPr lang="de-AT" sz="1800" b="0" baseline="-25000" dirty="0" err="1" smtClean="0"/>
-            </a:p>
-          </p:txBody>
-        </p:sp>
-        <p:sp>
-          <p:nvSpPr>
-            <p:cNvPr id="15" name="Textfeld 14"/>
-            <p:cNvSpPr txBox="1"/>
-            <p:nvPr/>
-          </p:nvSpPr>
-          <p:spPr>
-            <a:xfrm>
-              <a:off x="1978005" y="3833130"/>
-              <a:ext cx="603050" cy="369332"/>
-            </a:xfrm>
-            <a:prstGeom prst="rect">
-              <a:avLst/>
-            </a:prstGeom>
-            <a:noFill/>
-            <a:ln>
-              <a:noFill/>
-            </a:ln>
-          </p:spPr>
-          <p:txBody>
-            <a:bodyPr wrap="none" rtlCol="0">
-              <a:spAutoFit/>
-            </a:bodyPr>
-            <a:lstStyle/>
-            <a:p>
-              <a:pPr algn="l">
-                <a:spcBef>
-                  <a:spcPts val="0"/>
-                </a:spcBef>
-              </a:pPr>
-              <a:r>
-                <a:rPr lang="en-US" sz="1800" b="0" dirty="0" err="1" smtClean="0"/>
-                <a:t>a</a:t>
-              </a:r>
-              <a:r>
-                <a:rPr lang="en-US" sz="1800" b="0" baseline="-25000" dirty="0" err="1" smtClean="0"/>
-                <a:t>max</a:t>
-              </a:r>
-              <a:endParaRPr lang="de-AT" sz="1800" b="0" baseline="-25000" dirty="0" err="1" smtClean="0"/>
-            </a:p>
-          </p:txBody>
-        </p:sp>
-        <p:sp>
-          <p:nvSpPr>
-            <p:cNvPr id="17" name="Textfeld 16"/>
-            <p:cNvSpPr txBox="1"/>
-            <p:nvPr/>
-          </p:nvSpPr>
-          <p:spPr>
-            <a:xfrm>
-              <a:off x="4002613" y="6007350"/>
-              <a:ext cx="569387" cy="369332"/>
-            </a:xfrm>
-            <a:prstGeom prst="rect">
-              <a:avLst/>
-            </a:prstGeom>
-            <a:noFill/>
-            <a:ln>
-              <a:noFill/>
-            </a:ln>
-          </p:spPr>
-          <p:txBody>
-            <a:bodyPr wrap="none" rtlCol="0">
-              <a:spAutoFit/>
-            </a:bodyPr>
-            <a:lstStyle/>
-            <a:p>
-              <a:pPr algn="l">
-                <a:spcBef>
-                  <a:spcPts val="0"/>
-                </a:spcBef>
-              </a:pPr>
-              <a:r>
-                <a:rPr lang="en-US" sz="1800" b="0" dirty="0" smtClean="0"/>
-                <a:t>680</a:t>
-              </a:r>
-              <a:endParaRPr lang="de-AT" sz="1800" b="0" dirty="0" err="1" smtClean="0"/>
-            </a:p>
-          </p:txBody>
-        </p:sp>
-      </p:grpSp>
-      <p:sp>
-        <p:nvSpPr>
-          <p:cNvPr id="18" name="Textfeld 17"/>
-          <p:cNvSpPr txBox="1"/>
-          <p:nvPr/>
-        </p:nvSpPr>
-        <p:spPr>
-          <a:xfrm>
-            <a:off x="4092623" y="2708920"/>
-            <a:ext cx="1133644" cy="369332"/>
-          </a:xfrm>
-          <a:prstGeom prst="rect">
-            <a:avLst/>
-          </a:prstGeom>
-          <a:noFill/>
-          <a:ln>
-            <a:noFill/>
-          </a:ln>
-        </p:spPr>
-        <p:txBody>
-          <a:bodyPr wrap="none" rtlCol="0">
-            <a:spAutoFit/>
-          </a:bodyPr>
-          <a:lstStyle/>
-          <a:p>
-            <a:pPr algn="l">
-              <a:spcBef>
-                <a:spcPts val="0"/>
-              </a:spcBef>
-            </a:pPr>
-            <a:r>
-              <a:rPr lang="en-US" sz="1800" b="0" dirty="0" smtClean="0"/>
-              <a:t>0% slope</a:t>
-            </a:r>
-            <a:endParaRPr lang="de-AT" sz="1800" b="0" dirty="0" err="1" smtClean="0"/>
-          </a:p>
-        </p:txBody>
-      </p:sp>
-      <p:cxnSp>
-        <p:nvCxnSpPr>
-          <p:cNvPr id="20" name="Gerader Verbinder 19"/>
-          <p:cNvCxnSpPr/>
-          <p:nvPr/>
-        </p:nvCxnSpPr>
-        <p:spPr bwMode="auto">
-          <a:xfrm>
-            <a:off x="5367310" y="5373216"/>
-            <a:ext cx="0" cy="936104"/>
-          </a:xfrm>
-          <a:prstGeom prst="line">
-            <a:avLst/>
-          </a:prstGeom>
-          <a:solidFill>
-            <a:schemeClr val="accent1"/>
-          </a:solidFill>
-          <a:ln w="38100" cap="flat" cmpd="sng" algn="ctr">
-            <a:solidFill>
-              <a:srgbClr val="FF0000"/>
-            </a:solidFill>
-            <a:prstDash val="solid"/>
-            <a:round/>
-            <a:headEnd type="none" w="med" len="med"/>
-            <a:tailEnd type="none" w="med" len="med"/>
-          </a:ln>
-          <a:effectLst/>
-          <a:extLst>
-            <a:ext uri="{AF507438-7753-43E0-B8FC-AC1667EBCBE1}">
-              <a14:hiddenEffects xmlns:a14="http://schemas.microsoft.com/office/drawing/2010/main">
-                <a:effectLst>
-                  <a:outerShdw dist="35921" dir="2700000" algn="ctr" rotWithShape="0">
-                    <a:schemeClr val="bg2"/>
-                  </a:outerShdw>
-                </a:effectLst>
-              </a14:hiddenEffects>
-            </a:ext>
-          </a:extLst>
-        </p:spPr>
-      </p:cxnSp>
-      <p:sp>
-        <p:nvSpPr>
-          <p:cNvPr id="21" name="Textfeld 20"/>
-          <p:cNvSpPr txBox="1"/>
-          <p:nvPr/>
-        </p:nvSpPr>
-        <p:spPr>
-          <a:xfrm>
-            <a:off x="5403235" y="5956556"/>
-            <a:ext cx="569387" cy="369332"/>
-          </a:xfrm>
-          <a:prstGeom prst="rect">
-            <a:avLst/>
-          </a:prstGeom>
-          <a:noFill/>
-          <a:ln>
-            <a:noFill/>
-          </a:ln>
-        </p:spPr>
-        <p:txBody>
-          <a:bodyPr wrap="none" rtlCol="0">
-            <a:spAutoFit/>
-          </a:bodyPr>
-          <a:lstStyle/>
-          <a:p>
-            <a:pPr algn="l">
-              <a:spcBef>
-                <a:spcPts val="0"/>
-              </a:spcBef>
-            </a:pPr>
-            <a:r>
-              <a:rPr lang="en-US" sz="1800" b="0" dirty="0" smtClean="0"/>
-              <a:t>700</a:t>
-            </a:r>
-            <a:endParaRPr lang="de-AT" sz="1800" b="0" dirty="0" err="1" smtClean="0"/>
-          </a:p>
-        </p:txBody>
-      </p:sp>
-      <p:cxnSp>
-        <p:nvCxnSpPr>
-          <p:cNvPr id="22" name="Gerader Verbinder 21"/>
-          <p:cNvCxnSpPr/>
-          <p:nvPr/>
-        </p:nvCxnSpPr>
-        <p:spPr bwMode="auto">
-          <a:xfrm flipH="1" flipV="1">
-            <a:off x="4067944" y="4077073"/>
-            <a:ext cx="1308122" cy="1295626"/>
-          </a:xfrm>
-          <a:prstGeom prst="line">
-            <a:avLst/>
-          </a:prstGeom>
-          <a:solidFill>
-            <a:schemeClr val="accent1"/>
-          </a:solidFill>
-          <a:ln w="38100" cap="flat" cmpd="sng" algn="ctr">
-            <a:solidFill>
-              <a:srgbClr val="FF0000"/>
-            </a:solidFill>
-            <a:prstDash val="solid"/>
-            <a:round/>
-            <a:headEnd type="none" w="med" len="med"/>
-            <a:tailEnd type="none" w="med" len="med"/>
-          </a:ln>
-          <a:effectLst/>
-          <a:extLst>
-            <a:ext uri="{AF507438-7753-43E0-B8FC-AC1667EBCBE1}">
-              <a14:hiddenEffects xmlns:a14="http://schemas.microsoft.com/office/drawing/2010/main">
-                <a:effectLst>
-                  <a:outerShdw dist="35921" dir="2700000" algn="ctr" rotWithShape="0">
-                    <a:schemeClr val="bg2"/>
-                  </a:outerShdw>
-                </a:effectLst>
-              </a14:hiddenEffects>
-            </a:ext>
-          </a:extLst>
-        </p:spPr>
-      </p:cxnSp>
-      <p:cxnSp>
-        <p:nvCxnSpPr>
-          <p:cNvPr id="25" name="Gerader Verbinder 24"/>
-          <p:cNvCxnSpPr/>
-          <p:nvPr/>
-        </p:nvCxnSpPr>
-        <p:spPr bwMode="auto">
-          <a:xfrm flipH="1">
-            <a:off x="2674515" y="4069797"/>
-            <a:ext cx="3804389" cy="7276"/>
-          </a:xfrm>
-          <a:prstGeom prst="line">
-            <a:avLst/>
-          </a:prstGeom>
-          <a:solidFill>
-            <a:schemeClr val="accent1"/>
-          </a:solidFill>
-          <a:ln w="12700" cap="flat" cmpd="sng" algn="ctr">
-            <a:solidFill>
-              <a:schemeClr val="bg1">
-                <a:lumMod val="65000"/>
-              </a:schemeClr>
-            </a:solidFill>
-            <a:prstDash val="lgDash"/>
-            <a:round/>
-            <a:headEnd type="none" w="med" len="med"/>
-            <a:tailEnd type="none" w="med" len="med"/>
-          </a:ln>
-          <a:effectLst/>
-          <a:extLst>
-            <a:ext uri="{AF507438-7753-43E0-B8FC-AC1667EBCBE1}">
-              <a14:hiddenEffects xmlns:a14="http://schemas.microsoft.com/office/drawing/2010/main">
-                <a:effectLst>
-                  <a:outerShdw dist="35921" dir="2700000" algn="ctr" rotWithShape="0">
-                    <a:schemeClr val="bg2"/>
-                  </a:outerShdw>
-                </a:effectLst>
-              </a14:hiddenEffects>
-            </a:ext>
-          </a:extLst>
-        </p:spPr>
-      </p:cxnSp>
-      <p:cxnSp>
-        <p:nvCxnSpPr>
-          <p:cNvPr id="28" name="Gerader Verbinder 27"/>
-          <p:cNvCxnSpPr/>
-          <p:nvPr/>
-        </p:nvCxnSpPr>
-        <p:spPr bwMode="auto">
-          <a:xfrm flipH="1">
-            <a:off x="2627784" y="5365423"/>
-            <a:ext cx="3804389" cy="7276"/>
-          </a:xfrm>
-          <a:prstGeom prst="line">
-            <a:avLst/>
-          </a:prstGeom>
-          <a:solidFill>
-            <a:schemeClr val="accent1"/>
-          </a:solidFill>
-          <a:ln w="12700" cap="flat" cmpd="sng" algn="ctr">
-            <a:solidFill>
-              <a:schemeClr val="bg1">
-                <a:lumMod val="65000"/>
-              </a:schemeClr>
-            </a:solidFill>
-            <a:prstDash val="lgDash"/>
-            <a:round/>
-            <a:headEnd type="none" w="med" len="med"/>
-            <a:tailEnd type="none" w="med" len="med"/>
-          </a:ln>
-          <a:effectLst/>
-          <a:extLst>
-            <a:ext uri="{AF507438-7753-43E0-B8FC-AC1667EBCBE1}">
-              <a14:hiddenEffects xmlns:a14="http://schemas.microsoft.com/office/drawing/2010/main">
-                <a:effectLst>
-                  <a:outerShdw dist="35921" dir="2700000" algn="ctr" rotWithShape="0">
-                    <a:schemeClr val="bg2"/>
-                  </a:outerShdw>
-                </a:effectLst>
-              </a14:hiddenEffects>
-            </a:ext>
-          </a:extLst>
-        </p:spPr>
-      </p:cxnSp>
-      <p:cxnSp>
-        <p:nvCxnSpPr>
-          <p:cNvPr id="24" name="Gerader Verbinder 23"/>
-          <p:cNvCxnSpPr/>
-          <p:nvPr/>
-        </p:nvCxnSpPr>
-        <p:spPr bwMode="auto">
-          <a:xfrm>
-            <a:off x="4067944" y="3140968"/>
-            <a:ext cx="0" cy="936104"/>
-          </a:xfrm>
-          <a:prstGeom prst="line">
-            <a:avLst/>
-          </a:prstGeom>
-          <a:solidFill>
-            <a:schemeClr val="accent1"/>
-          </a:solidFill>
-          <a:ln w="38100" cap="flat" cmpd="sng" algn="ctr">
-            <a:solidFill>
-              <a:srgbClr val="FF0000"/>
-            </a:solidFill>
-            <a:prstDash val="solid"/>
-            <a:round/>
-            <a:headEnd type="none" w="med" len="med"/>
-            <a:tailEnd type="none" w="med" len="med"/>
-          </a:ln>
-          <a:effectLst/>
-          <a:extLst>
-            <a:ext uri="{AF507438-7753-43E0-B8FC-AC1667EBCBE1}">
-              <a14:hiddenEffects xmlns:a14="http://schemas.microsoft.com/office/drawing/2010/main">
-                <a:effectLst>
-                  <a:outerShdw dist="35921" dir="2700000" algn="ctr" rotWithShape="0">
-                    <a:schemeClr val="bg2"/>
-                  </a:outerShdw>
-                </a:effectLst>
-              </a14:hiddenEffects>
-            </a:ext>
-          </a:extLst>
-        </p:spPr>
-      </p:cxnSp>
-      <p:cxnSp>
-        <p:nvCxnSpPr>
-          <p:cNvPr id="26" name="Gerader Verbinder 25"/>
-          <p:cNvCxnSpPr/>
-          <p:nvPr/>
-        </p:nvCxnSpPr>
-        <p:spPr bwMode="auto">
-          <a:xfrm>
-            <a:off x="6705442" y="5386258"/>
-            <a:ext cx="0" cy="936104"/>
-          </a:xfrm>
-          <a:prstGeom prst="line">
-            <a:avLst/>
-          </a:prstGeom>
-          <a:solidFill>
-            <a:schemeClr val="accent1"/>
-          </a:solidFill>
-          <a:ln w="38100" cap="flat" cmpd="sng" algn="ctr">
-            <a:solidFill>
-              <a:srgbClr val="0066FF"/>
-            </a:solidFill>
-            <a:prstDash val="solid"/>
-            <a:round/>
-            <a:headEnd type="none" w="med" len="med"/>
-            <a:tailEnd type="none" w="med" len="med"/>
-          </a:ln>
-          <a:effectLst/>
-          <a:extLst>
-            <a:ext uri="{AF507438-7753-43E0-B8FC-AC1667EBCBE1}">
-              <a14:hiddenEffects xmlns:a14="http://schemas.microsoft.com/office/drawing/2010/main">
-                <a:effectLst>
-                  <a:outerShdw dist="35921" dir="2700000" algn="ctr" rotWithShape="0">
-                    <a:schemeClr val="bg2"/>
-                  </a:outerShdw>
-                </a:effectLst>
-              </a14:hiddenEffects>
-            </a:ext>
-          </a:extLst>
-        </p:spPr>
-      </p:cxnSp>
-      <p:cxnSp>
-        <p:nvCxnSpPr>
-          <p:cNvPr id="27" name="Gerader Verbinder 26"/>
-          <p:cNvCxnSpPr/>
-          <p:nvPr/>
-        </p:nvCxnSpPr>
-        <p:spPr bwMode="auto">
-          <a:xfrm flipH="1" flipV="1">
-            <a:off x="5406076" y="4090115"/>
-            <a:ext cx="1308122" cy="1295626"/>
-          </a:xfrm>
-          <a:prstGeom prst="line">
-            <a:avLst/>
-          </a:prstGeom>
-          <a:solidFill>
-            <a:schemeClr val="accent1"/>
-          </a:solidFill>
-          <a:ln w="38100" cap="flat" cmpd="sng" algn="ctr">
-            <a:solidFill>
-              <a:srgbClr val="0066FF"/>
-            </a:solidFill>
-            <a:prstDash val="solid"/>
-            <a:round/>
-            <a:headEnd type="none" w="med" len="med"/>
-            <a:tailEnd type="none" w="med" len="med"/>
-          </a:ln>
-          <a:effectLst/>
-          <a:extLst>
-            <a:ext uri="{AF507438-7753-43E0-B8FC-AC1667EBCBE1}">
-              <a14:hiddenEffects xmlns:a14="http://schemas.microsoft.com/office/drawing/2010/main">
-                <a:effectLst>
-                  <a:outerShdw dist="35921" dir="2700000" algn="ctr" rotWithShape="0">
-                    <a:schemeClr val="bg2"/>
-                  </a:outerShdw>
-                </a:effectLst>
-              </a14:hiddenEffects>
-            </a:ext>
-          </a:extLst>
-        </p:spPr>
-      </p:cxnSp>
-      <p:cxnSp>
-        <p:nvCxnSpPr>
-          <p:cNvPr id="29" name="Gerader Verbinder 28"/>
-          <p:cNvCxnSpPr/>
-          <p:nvPr/>
-        </p:nvCxnSpPr>
-        <p:spPr bwMode="auto">
-          <a:xfrm>
-            <a:off x="5406076" y="3154010"/>
-            <a:ext cx="0" cy="936104"/>
-          </a:xfrm>
-          <a:prstGeom prst="line">
-            <a:avLst/>
-          </a:prstGeom>
-          <a:solidFill>
-            <a:schemeClr val="accent1"/>
-          </a:solidFill>
-          <a:ln w="38100" cap="flat" cmpd="sng" algn="ctr">
-            <a:solidFill>
-              <a:srgbClr val="0066FF"/>
-            </a:solidFill>
-            <a:prstDash val="solid"/>
-            <a:round/>
-            <a:headEnd type="none" w="med" len="med"/>
-            <a:tailEnd type="none" w="med" len="med"/>
-          </a:ln>
-          <a:effectLst/>
-          <a:extLst>
-            <a:ext uri="{AF507438-7753-43E0-B8FC-AC1667EBCBE1}">
-              <a14:hiddenEffects xmlns:a14="http://schemas.microsoft.com/office/drawing/2010/main">
-                <a:effectLst>
-                  <a:outerShdw dist="35921" dir="2700000" algn="ctr" rotWithShape="0">
-                    <a:schemeClr val="bg2"/>
-                  </a:outerShdw>
-                </a:effectLst>
-              </a14:hiddenEffects>
-            </a:ext>
-          </a:extLst>
-        </p:spPr>
-      </p:cxnSp>
-      <p:sp>
-        <p:nvSpPr>
-          <p:cNvPr id="30" name="Textfeld 29"/>
-          <p:cNvSpPr txBox="1"/>
-          <p:nvPr/>
-        </p:nvSpPr>
-        <p:spPr>
-          <a:xfrm>
-            <a:off x="6666909" y="5956556"/>
-            <a:ext cx="569387" cy="369332"/>
-          </a:xfrm>
-          <a:prstGeom prst="rect">
-            <a:avLst/>
-          </a:prstGeom>
-          <a:noFill/>
-          <a:ln>
-            <a:noFill/>
-          </a:ln>
-        </p:spPr>
-        <p:txBody>
-          <a:bodyPr wrap="none" rtlCol="0">
-            <a:spAutoFit/>
-          </a:bodyPr>
-          <a:lstStyle/>
-          <a:p>
-            <a:pPr algn="l">
-              <a:spcBef>
-                <a:spcPts val="0"/>
-              </a:spcBef>
-            </a:pPr>
-            <a:r>
-              <a:rPr lang="en-US" sz="1800" b="0" dirty="0" smtClean="0"/>
-              <a:t>720</a:t>
-            </a:r>
-            <a:endParaRPr lang="de-AT" sz="1800" b="0" dirty="0" err="1" smtClean="0"/>
-          </a:p>
-        </p:txBody>
-      </p:sp>
-      <p:cxnSp>
-        <p:nvCxnSpPr>
-          <p:cNvPr id="35" name="Gerader Verbinder 34"/>
-          <p:cNvCxnSpPr/>
-          <p:nvPr/>
-        </p:nvCxnSpPr>
-        <p:spPr bwMode="auto">
-          <a:xfrm>
-            <a:off x="6028679" y="5351151"/>
-            <a:ext cx="0" cy="936104"/>
-          </a:xfrm>
-          <a:prstGeom prst="line">
-            <a:avLst/>
-          </a:prstGeom>
-          <a:solidFill>
-            <a:schemeClr val="accent1"/>
-          </a:solidFill>
-          <a:ln w="38100" cap="flat" cmpd="sng" algn="ctr">
-            <a:solidFill>
-              <a:schemeClr val="bg1">
-                <a:lumMod val="65000"/>
-              </a:schemeClr>
-            </a:solidFill>
-            <a:prstDash val="solid"/>
-            <a:round/>
-            <a:headEnd type="none" w="med" len="med"/>
-            <a:tailEnd type="none" w="med" len="med"/>
-          </a:ln>
-          <a:effectLst/>
-          <a:extLst>
-            <a:ext uri="{AF507438-7753-43E0-B8FC-AC1667EBCBE1}">
-              <a14:hiddenEffects xmlns:a14="http://schemas.microsoft.com/office/drawing/2010/main">
-                <a:effectLst>
-                  <a:outerShdw dist="35921" dir="2700000" algn="ctr" rotWithShape="0">
-                    <a:schemeClr val="bg2"/>
-                  </a:outerShdw>
-                </a:effectLst>
-              </a14:hiddenEffects>
-            </a:ext>
-          </a:extLst>
-        </p:spPr>
-      </p:cxnSp>
-      <p:cxnSp>
-        <p:nvCxnSpPr>
-          <p:cNvPr id="36" name="Gerader Verbinder 35"/>
-          <p:cNvCxnSpPr/>
-          <p:nvPr/>
-        </p:nvCxnSpPr>
-        <p:spPr bwMode="auto">
-          <a:xfrm flipH="1" flipV="1">
-            <a:off x="4729313" y="4055008"/>
-            <a:ext cx="1308122" cy="1295626"/>
-          </a:xfrm>
-          <a:prstGeom prst="line">
-            <a:avLst/>
-          </a:prstGeom>
-          <a:solidFill>
-            <a:schemeClr val="accent1"/>
-          </a:solidFill>
-          <a:ln w="38100" cap="flat" cmpd="sng" algn="ctr">
-            <a:solidFill>
-              <a:schemeClr val="bg1">
-                <a:lumMod val="65000"/>
-              </a:schemeClr>
-            </a:solidFill>
-            <a:prstDash val="solid"/>
-            <a:round/>
-            <a:headEnd type="none" w="med" len="med"/>
-            <a:tailEnd type="none" w="med" len="med"/>
-          </a:ln>
-          <a:effectLst/>
-          <a:extLst>
-            <a:ext uri="{AF507438-7753-43E0-B8FC-AC1667EBCBE1}">
-              <a14:hiddenEffects xmlns:a14="http://schemas.microsoft.com/office/drawing/2010/main">
-                <a:effectLst>
-                  <a:outerShdw dist="35921" dir="2700000" algn="ctr" rotWithShape="0">
-                    <a:schemeClr val="bg2"/>
-                  </a:outerShdw>
-                </a:effectLst>
-              </a14:hiddenEffects>
-            </a:ext>
-          </a:extLst>
-        </p:spPr>
-      </p:cxnSp>
-      <p:cxnSp>
-        <p:nvCxnSpPr>
-          <p:cNvPr id="37" name="Gerader Verbinder 36"/>
-          <p:cNvCxnSpPr/>
-          <p:nvPr/>
-        </p:nvCxnSpPr>
-        <p:spPr bwMode="auto">
-          <a:xfrm>
-            <a:off x="4729313" y="3118903"/>
-            <a:ext cx="0" cy="936104"/>
-          </a:xfrm>
-          <a:prstGeom prst="line">
-            <a:avLst/>
-          </a:prstGeom>
-          <a:solidFill>
-            <a:schemeClr val="accent1"/>
-          </a:solidFill>
-          <a:ln w="38100" cap="flat" cmpd="sng" algn="ctr">
-            <a:solidFill>
-              <a:schemeClr val="bg1">
-                <a:lumMod val="65000"/>
-              </a:schemeClr>
-            </a:solidFill>
-            <a:prstDash val="solid"/>
-            <a:round/>
-            <a:headEnd type="none" w="med" len="med"/>
-            <a:tailEnd type="none" w="med" len="med"/>
-          </a:ln>
-          <a:effectLst/>
-          <a:extLst>
-            <a:ext uri="{AF507438-7753-43E0-B8FC-AC1667EBCBE1}">
-              <a14:hiddenEffects xmlns:a14="http://schemas.microsoft.com/office/drawing/2010/main">
-                <a:effectLst>
-                  <a:outerShdw dist="35921" dir="2700000" algn="ctr" rotWithShape="0">
-                    <a:schemeClr val="bg2"/>
-                  </a:outerShdw>
-                </a:effectLst>
-              </a14:hiddenEffects>
-            </a:ext>
-          </a:extLst>
-        </p:spPr>
-      </p:cxnSp>
-      <p:sp>
-        <p:nvSpPr>
-          <p:cNvPr id="38" name="Textfeld 37"/>
-          <p:cNvSpPr txBox="1"/>
-          <p:nvPr/>
-        </p:nvSpPr>
-        <p:spPr>
-          <a:xfrm>
-            <a:off x="5923115" y="3181103"/>
-            <a:ext cx="2056973" cy="369332"/>
-          </a:xfrm>
-          <a:prstGeom prst="rect">
-            <a:avLst/>
-          </a:prstGeom>
-          <a:noFill/>
-          <a:ln>
-            <a:noFill/>
-          </a:ln>
-        </p:spPr>
-        <p:txBody>
-          <a:bodyPr wrap="none" rtlCol="0">
-            <a:spAutoFit/>
-          </a:bodyPr>
-          <a:lstStyle/>
-          <a:p>
-            <a:pPr algn="l">
-              <a:spcBef>
-                <a:spcPts val="0"/>
-              </a:spcBef>
-            </a:pPr>
-            <a:r>
-              <a:rPr lang="en-US" sz="1800" b="0" dirty="0" smtClean="0"/>
-              <a:t>Resulting shift line</a:t>
-            </a:r>
-            <a:endParaRPr lang="de-AT" sz="1800" b="0" dirty="0" err="1" smtClean="0"/>
-          </a:p>
-        </p:txBody>
-      </p:sp>
-      <p:cxnSp>
-        <p:nvCxnSpPr>
-          <p:cNvPr id="40" name="Gerade Verbindung mit Pfeil 39"/>
-          <p:cNvCxnSpPr>
-            <a:stCxn id="38" idx="1"/>
-          </p:cNvCxnSpPr>
-          <p:nvPr/>
-        </p:nvCxnSpPr>
-        <p:spPr bwMode="auto">
-          <a:xfrm flipH="1">
-            <a:off x="4729313" y="3365769"/>
-            <a:ext cx="1193802" cy="403113"/>
-          </a:xfrm>
-          <a:prstGeom prst="straightConnector1">
-            <a:avLst/>
-          </a:prstGeom>
-          <a:solidFill>
-            <a:schemeClr val="accent1"/>
-          </a:solidFill>
-          <a:ln w="12700" cap="flat" cmpd="sng" algn="ctr">
-            <a:solidFill>
-              <a:schemeClr val="tx1"/>
-            </a:solidFill>
-            <a:prstDash val="solid"/>
-            <a:round/>
-            <a:headEnd type="none" w="med" len="med"/>
-            <a:tailEnd type="triangle"/>
-          </a:ln>
-          <a:effectLst/>
-          <a:extLst>
-            <a:ext uri="{AF507438-7753-43E0-B8FC-AC1667EBCBE1}">
-              <a14:hiddenEffects xmlns:a14="http://schemas.microsoft.com/office/drawing/2010/main">
-                <a:effectLst>
-                  <a:outerShdw dist="35921" dir="2700000" algn="ctr" rotWithShape="0">
-                    <a:schemeClr val="bg2"/>
-                  </a:outerShdw>
-                </a:effectLst>
-              </a14:hiddenEffects>
-            </a:ext>
-          </a:extLst>
-        </p:spPr>
-      </p:cxnSp>
-    </p:spTree>
-    <p:extLst>
-      <p:ext uri="{BB962C8B-B14F-4D97-AF65-F5344CB8AC3E}">
-        <p14:creationId xmlns:p14="http://schemas.microsoft.com/office/powerpoint/2010/main" val="837087122"/>
-      </p:ext>
-    </p:extLst>
-  </p:cSld>
-  <p:clrMapOvr>
-    <a:masterClrMapping/>
-  </p:clrMapOvr>
-  <p:timing>
-    <p:tnLst>
-      <p:par>
-        <p:cTn id="1" dur="indefinite" restart="never" nodeType="tmRoot"/>
-      </p:par>
-    </p:tnLst>
-  </p:timing>
-</p:sld>
-</file>
-
-<file path=ppt/slides/slide17.xml><?xml version="1.0" encoding="utf-8"?>
-<p:sld xmlns:a="http://schemas.openxmlformats.org/drawingml/2006/main" xmlns:r="http://schemas.openxmlformats.org/officeDocument/2006/relationships" xmlns:p="http://schemas.openxmlformats.org/presentationml/2006/main">
-  <p:cSld>
-    <p:spTree>
-      <p:nvGrpSpPr>
-        <p:cNvPr id="1" name=""/>
-        <p:cNvGrpSpPr/>
-        <p:nvPr/>
-      </p:nvGrpSpPr>
-      <p:grpSpPr>
-        <a:xfrm>
-          <a:off x="0" y="0"/>
-          <a:ext cx="0" cy="0"/>
-          <a:chOff x="0" y="0"/>
-          <a:chExt cx="0" cy="0"/>
-        </a:xfrm>
-      </p:grpSpPr>
-      <p:sp>
-        <p:nvSpPr>
-          <p:cNvPr id="2" name="Titel 1"/>
-          <p:cNvSpPr>
-            <a:spLocks noGrp="1"/>
-          </p:cNvSpPr>
-          <p:nvPr>
-            <p:ph type="title"/>
-          </p:nvPr>
-        </p:nvSpPr>
         <p:spPr/>
         <p:txBody>
           <a:bodyPr/>
@@ -9218,7 +7754,7 @@
 </p:sld>
 </file>
 
-<file path=ppt/slides/slide18.xml><?xml version="1.0" encoding="utf-8"?>
+<file path=ppt/slides/slide17.xml><?xml version="1.0" encoding="utf-8"?>
 <p:sld xmlns:a="http://schemas.openxmlformats.org/drawingml/2006/main" xmlns:r="http://schemas.openxmlformats.org/officeDocument/2006/relationships" xmlns:p="http://schemas.openxmlformats.org/presentationml/2006/main">
   <p:cSld>
     <p:spTree>
@@ -9441,7 +7977,7 @@
 </p:sld>
 </file>
 
-<file path=ppt/slides/slide19.xml><?xml version="1.0" encoding="utf-8"?>
+<file path=ppt/slides/slide18.xml><?xml version="1.0" encoding="utf-8"?>
 <p:sld xmlns:a="http://schemas.openxmlformats.org/drawingml/2006/main" xmlns:r="http://schemas.openxmlformats.org/officeDocument/2006/relationships" xmlns:p="http://schemas.openxmlformats.org/presentationml/2006/main">
   <p:cSld>
     <p:spTree>

</xml_diff>